<commit_message>
Created yes- no-events for probability forecasts
</commit_message>
<xml_diff>
--- a/chapter_05/figures/definition_yes_non_events.pptx
+++ b/chapter_05/figures/definition_yes_non_events.pptx
@@ -2,12 +2,12 @@
 <file path=ppt/presentation.xml><?xml version="1.0" encoding="utf-8"?>
 <p:presentation xmlns:a="http://schemas.openxmlformats.org/drawingml/2006/main" xmlns:r="http://schemas.openxmlformats.org/officeDocument/2006/relationships" xmlns:p="http://schemas.openxmlformats.org/presentationml/2006/main" saveSubsetFonts="1">
   <p:sldMasterIdLst>
-    <p:sldMasterId id="2147483696" r:id="rId1"/>
+    <p:sldMasterId id="2147483720" r:id="rId1"/>
   </p:sldMasterIdLst>
   <p:sldIdLst>
     <p:sldId id="256" r:id="rId2"/>
   </p:sldIdLst>
-  <p:sldSz cx="4140200" cy="4572000"/>
+  <p:sldSz cx="4140200" cy="4319588"/>
   <p:notesSz cx="6858000" cy="9144000"/>
   <p:defaultTextStyle>
     <a:defPPr>
@@ -104,7 +104,441 @@
       </a:defRPr>
     </a:lvl9pPr>
   </p:defaultTextStyle>
+  <p:extLst>
+    <p:ext uri="{EFAFB233-063F-42B5-8137-9DF3F51BA10A}">
+      <p15:sldGuideLst xmlns:p15="http://schemas.microsoft.com/office/powerpoint/2012/main"/>
+    </p:ext>
+  </p:extLst>
 </p:presentation>
+</file>
+
+<file path=ppt/revisionInfo.xml><?xml version="1.0" encoding="utf-8"?>
+<p1510:revInfo xmlns:a="http://schemas.openxmlformats.org/drawingml/2006/main" xmlns:r="http://schemas.openxmlformats.org/officeDocument/2006/relationships" xmlns:p1510="http://schemas.microsoft.com/office/powerpoint/2015/10/main">
+  <p1510:revLst>
+    <p1510:client id="{A7D5681F-9D70-48A9-B968-7127EE2335D0}" v="6" dt="2026-01-26T17:07:29.033"/>
+  </p1510:revLst>
+</p1510:revInfo>
+</file>
+
+<file path=ppt/changesInfos/changesInfo1.xml><?xml version="1.0" encoding="utf-8"?>
+<pc:chgInfo xmlns:a="http://schemas.openxmlformats.org/drawingml/2006/main" xmlns:r="http://schemas.openxmlformats.org/officeDocument/2006/relationships" xmlns:ac="http://schemas.microsoft.com/office/drawing/2013/main/command" xmlns:pc="http://schemas.microsoft.com/office/powerpoint/2013/main/command">
+  <pc:docChgLst>
+    <pc:chgData name="Fatima Pillosu" userId="a6295d4dc9e22643" providerId="LiveId" clId="{87453732-75AC-4426-B5D3-B7C69C2D4F54}"/>
+    <pc:docChg chg="undo custSel modSld">
+      <pc:chgData name="Fatima Pillosu" userId="a6295d4dc9e22643" providerId="LiveId" clId="{87453732-75AC-4426-B5D3-B7C69C2D4F54}" dt="2026-01-26T17:10:17.229" v="204" actId="1076"/>
+      <pc:docMkLst>
+        <pc:docMk/>
+      </pc:docMkLst>
+      <pc:sldChg chg="addSp delSp modSp mod">
+        <pc:chgData name="Fatima Pillosu" userId="a6295d4dc9e22643" providerId="LiveId" clId="{87453732-75AC-4426-B5D3-B7C69C2D4F54}" dt="2026-01-26T17:10:17.229" v="204" actId="1076"/>
+        <pc:sldMkLst>
+          <pc:docMk/>
+          <pc:sldMk cId="2922174619" sldId="256"/>
+        </pc:sldMkLst>
+        <pc:spChg chg="add del mod">
+          <ac:chgData name="Fatima Pillosu" userId="a6295d4dc9e22643" providerId="LiveId" clId="{87453732-75AC-4426-B5D3-B7C69C2D4F54}" dt="2026-01-26T17:06:51.446" v="158" actId="21"/>
+          <ac:spMkLst>
+            <pc:docMk/>
+            <pc:sldMk cId="2922174619" sldId="256"/>
+            <ac:spMk id="2" creationId="{4FF56070-D238-C224-AA97-E058A81BE633}"/>
+          </ac:spMkLst>
+        </pc:spChg>
+        <pc:spChg chg="mod">
+          <ac:chgData name="Fatima Pillosu" userId="a6295d4dc9e22643" providerId="LiveId" clId="{87453732-75AC-4426-B5D3-B7C69C2D4F54}" dt="2026-01-26T16:29:27.510" v="132" actId="1076"/>
+          <ac:spMkLst>
+            <pc:docMk/>
+            <pc:sldMk cId="2922174619" sldId="256"/>
+            <ac:spMk id="4" creationId="{0BB2AAB9-265F-B714-DBA2-FF13C3B6D595}"/>
+          </ac:spMkLst>
+        </pc:spChg>
+        <pc:spChg chg="del mod">
+          <ac:chgData name="Fatima Pillosu" userId="a6295d4dc9e22643" providerId="LiveId" clId="{87453732-75AC-4426-B5D3-B7C69C2D4F54}" dt="2026-01-26T17:06:51.446" v="158" actId="21"/>
+          <ac:spMkLst>
+            <pc:docMk/>
+            <pc:sldMk cId="2922174619" sldId="256"/>
+            <ac:spMk id="6" creationId="{5EA3B3E5-BDE1-8300-691A-8B995A0278E4}"/>
+          </ac:spMkLst>
+        </pc:spChg>
+        <pc:spChg chg="add del mod">
+          <ac:chgData name="Fatima Pillosu" userId="a6295d4dc9e22643" providerId="LiveId" clId="{87453732-75AC-4426-B5D3-B7C69C2D4F54}" dt="2026-01-26T17:06:51.446" v="158" actId="21"/>
+          <ac:spMkLst>
+            <pc:docMk/>
+            <pc:sldMk cId="2922174619" sldId="256"/>
+            <ac:spMk id="8" creationId="{A15B6D45-79F5-B9F8-C9E6-C2B4A302D2EA}"/>
+          </ac:spMkLst>
+        </pc:spChg>
+        <pc:spChg chg="add del mod">
+          <ac:chgData name="Fatima Pillosu" userId="a6295d4dc9e22643" providerId="LiveId" clId="{87453732-75AC-4426-B5D3-B7C69C2D4F54}" dt="2026-01-26T17:06:51.446" v="158" actId="21"/>
+          <ac:spMkLst>
+            <pc:docMk/>
+            <pc:sldMk cId="2922174619" sldId="256"/>
+            <ac:spMk id="9" creationId="{C12DC1C5-1801-3D4B-2A03-DAB145A118F6}"/>
+          </ac:spMkLst>
+        </pc:spChg>
+        <pc:spChg chg="add del mod">
+          <ac:chgData name="Fatima Pillosu" userId="a6295d4dc9e22643" providerId="LiveId" clId="{87453732-75AC-4426-B5D3-B7C69C2D4F54}" dt="2026-01-26T17:06:51.446" v="158" actId="21"/>
+          <ac:spMkLst>
+            <pc:docMk/>
+            <pc:sldMk cId="2922174619" sldId="256"/>
+            <ac:spMk id="16" creationId="{AEF2F405-62A6-9184-E2DA-F8586E4DAAA1}"/>
+          </ac:spMkLst>
+        </pc:spChg>
+        <pc:spChg chg="add del mod">
+          <ac:chgData name="Fatima Pillosu" userId="a6295d4dc9e22643" providerId="LiveId" clId="{87453732-75AC-4426-B5D3-B7C69C2D4F54}" dt="2026-01-26T17:06:51.446" v="158" actId="21"/>
+          <ac:spMkLst>
+            <pc:docMk/>
+            <pc:sldMk cId="2922174619" sldId="256"/>
+            <ac:spMk id="17" creationId="{3AC1E00C-7CC8-E558-16F9-CBB16592A278}"/>
+          </ac:spMkLst>
+        </pc:spChg>
+        <pc:spChg chg="add del mod">
+          <ac:chgData name="Fatima Pillosu" userId="a6295d4dc9e22643" providerId="LiveId" clId="{87453732-75AC-4426-B5D3-B7C69C2D4F54}" dt="2026-01-26T17:06:51.446" v="158" actId="21"/>
+          <ac:spMkLst>
+            <pc:docMk/>
+            <pc:sldMk cId="2922174619" sldId="256"/>
+            <ac:spMk id="18" creationId="{E2C60F2E-5AEC-FD98-E016-93A8494C37D8}"/>
+          </ac:spMkLst>
+        </pc:spChg>
+        <pc:spChg chg="add del mod">
+          <ac:chgData name="Fatima Pillosu" userId="a6295d4dc9e22643" providerId="LiveId" clId="{87453732-75AC-4426-B5D3-B7C69C2D4F54}" dt="2026-01-26T17:06:51.446" v="158" actId="21"/>
+          <ac:spMkLst>
+            <pc:docMk/>
+            <pc:sldMk cId="2922174619" sldId="256"/>
+            <ac:spMk id="19" creationId="{094E29AE-C474-3CCD-52C0-D085CCBD05CB}"/>
+          </ac:spMkLst>
+        </pc:spChg>
+        <pc:spChg chg="add mod">
+          <ac:chgData name="Fatima Pillosu" userId="a6295d4dc9e22643" providerId="LiveId" clId="{87453732-75AC-4426-B5D3-B7C69C2D4F54}" dt="2026-01-26T16:30:13.073" v="140" actId="1076"/>
+          <ac:spMkLst>
+            <pc:docMk/>
+            <pc:sldMk cId="2922174619" sldId="256"/>
+            <ac:spMk id="25" creationId="{3041A462-13E8-E68B-ED83-34E69527A7C3}"/>
+          </ac:spMkLst>
+        </pc:spChg>
+        <pc:spChg chg="add mod">
+          <ac:chgData name="Fatima Pillosu" userId="a6295d4dc9e22643" providerId="LiveId" clId="{87453732-75AC-4426-B5D3-B7C69C2D4F54}" dt="2026-01-26T16:28:29.149" v="121" actId="164"/>
+          <ac:spMkLst>
+            <pc:docMk/>
+            <pc:sldMk cId="2922174619" sldId="256"/>
+            <ac:spMk id="26" creationId="{0ABB75E4-DC24-C31B-F4F0-D6035B2DC0CC}"/>
+          </ac:spMkLst>
+        </pc:spChg>
+        <pc:spChg chg="add del">
+          <ac:chgData name="Fatima Pillosu" userId="a6295d4dc9e22643" providerId="LiveId" clId="{87453732-75AC-4426-B5D3-B7C69C2D4F54}" dt="2026-01-26T17:06:14.916" v="155" actId="478"/>
+          <ac:spMkLst>
+            <pc:docMk/>
+            <pc:sldMk cId="2922174619" sldId="256"/>
+            <ac:spMk id="29" creationId="{9455B3A6-BA71-93FF-AB36-02F255C63458}"/>
+          </ac:spMkLst>
+        </pc:spChg>
+        <pc:spChg chg="add del">
+          <ac:chgData name="Fatima Pillosu" userId="a6295d4dc9e22643" providerId="LiveId" clId="{87453732-75AC-4426-B5D3-B7C69C2D4F54}" dt="2026-01-26T17:06:49.342" v="157" actId="478"/>
+          <ac:spMkLst>
+            <pc:docMk/>
+            <pc:sldMk cId="2922174619" sldId="256"/>
+            <ac:spMk id="30" creationId="{4466E695-D3B6-22D6-FAAE-8A2F937A736C}"/>
+          </ac:spMkLst>
+        </pc:spChg>
+        <pc:spChg chg="add mod">
+          <ac:chgData name="Fatima Pillosu" userId="a6295d4dc9e22643" providerId="LiveId" clId="{87453732-75AC-4426-B5D3-B7C69C2D4F54}" dt="2026-01-26T17:07:44.629" v="169" actId="255"/>
+          <ac:spMkLst>
+            <pc:docMk/>
+            <pc:sldMk cId="2922174619" sldId="256"/>
+            <ac:spMk id="31" creationId="{4FF56070-D238-C224-AA97-E058A81BE633}"/>
+          </ac:spMkLst>
+        </pc:spChg>
+        <pc:spChg chg="mod">
+          <ac:chgData name="Fatima Pillosu" userId="a6295d4dc9e22643" providerId="LiveId" clId="{87453732-75AC-4426-B5D3-B7C69C2D4F54}" dt="2026-01-26T17:10:17.229" v="204" actId="1076"/>
+          <ac:spMkLst>
+            <pc:docMk/>
+            <pc:sldMk cId="2922174619" sldId="256"/>
+            <ac:spMk id="33" creationId="{0BB2AAB9-265F-B714-DBA2-FF13C3B6D595}"/>
+          </ac:spMkLst>
+        </pc:spChg>
+        <pc:spChg chg="mod">
+          <ac:chgData name="Fatima Pillosu" userId="a6295d4dc9e22643" providerId="LiveId" clId="{87453732-75AC-4426-B5D3-B7C69C2D4F54}" dt="2026-01-26T17:07:29.033" v="167" actId="164"/>
+          <ac:spMkLst>
+            <pc:docMk/>
+            <pc:sldMk cId="2922174619" sldId="256"/>
+            <ac:spMk id="35" creationId="{5EA3B3E5-BDE1-8300-691A-8B995A0278E4}"/>
+          </ac:spMkLst>
+        </pc:spChg>
+        <pc:spChg chg="add mod">
+          <ac:chgData name="Fatima Pillosu" userId="a6295d4dc9e22643" providerId="LiveId" clId="{87453732-75AC-4426-B5D3-B7C69C2D4F54}" dt="2026-01-26T17:07:29.033" v="167" actId="164"/>
+          <ac:spMkLst>
+            <pc:docMk/>
+            <pc:sldMk cId="2922174619" sldId="256"/>
+            <ac:spMk id="37" creationId="{A15B6D45-79F5-B9F8-C9E6-C2B4A302D2EA}"/>
+          </ac:spMkLst>
+        </pc:spChg>
+        <pc:spChg chg="add mod">
+          <ac:chgData name="Fatima Pillosu" userId="a6295d4dc9e22643" providerId="LiveId" clId="{87453732-75AC-4426-B5D3-B7C69C2D4F54}" dt="2026-01-26T17:07:29.033" v="167" actId="164"/>
+          <ac:spMkLst>
+            <pc:docMk/>
+            <pc:sldMk cId="2922174619" sldId="256"/>
+            <ac:spMk id="38" creationId="{C12DC1C5-1801-3D4B-2A03-DAB145A118F6}"/>
+          </ac:spMkLst>
+        </pc:spChg>
+        <pc:spChg chg="add mod">
+          <ac:chgData name="Fatima Pillosu" userId="a6295d4dc9e22643" providerId="LiveId" clId="{87453732-75AC-4426-B5D3-B7C69C2D4F54}" dt="2026-01-26T17:07:29.033" v="167" actId="164"/>
+          <ac:spMkLst>
+            <pc:docMk/>
+            <pc:sldMk cId="2922174619" sldId="256"/>
+            <ac:spMk id="45" creationId="{AEF2F405-62A6-9184-E2DA-F8586E4DAAA1}"/>
+          </ac:spMkLst>
+        </pc:spChg>
+        <pc:spChg chg="add mod">
+          <ac:chgData name="Fatima Pillosu" userId="a6295d4dc9e22643" providerId="LiveId" clId="{87453732-75AC-4426-B5D3-B7C69C2D4F54}" dt="2026-01-26T17:07:29.033" v="167" actId="164"/>
+          <ac:spMkLst>
+            <pc:docMk/>
+            <pc:sldMk cId="2922174619" sldId="256"/>
+            <ac:spMk id="46" creationId="{3AC1E00C-7CC8-E558-16F9-CBB16592A278}"/>
+          </ac:spMkLst>
+        </pc:spChg>
+        <pc:spChg chg="add mod">
+          <ac:chgData name="Fatima Pillosu" userId="a6295d4dc9e22643" providerId="LiveId" clId="{87453732-75AC-4426-B5D3-B7C69C2D4F54}" dt="2026-01-26T17:07:29.033" v="167" actId="164"/>
+          <ac:spMkLst>
+            <pc:docMk/>
+            <pc:sldMk cId="2922174619" sldId="256"/>
+            <ac:spMk id="47" creationId="{E2C60F2E-5AEC-FD98-E016-93A8494C37D8}"/>
+          </ac:spMkLst>
+        </pc:spChg>
+        <pc:spChg chg="add mod">
+          <ac:chgData name="Fatima Pillosu" userId="a6295d4dc9e22643" providerId="LiveId" clId="{87453732-75AC-4426-B5D3-B7C69C2D4F54}" dt="2026-01-26T17:07:29.033" v="167" actId="164"/>
+          <ac:spMkLst>
+            <pc:docMk/>
+            <pc:sldMk cId="2922174619" sldId="256"/>
+            <ac:spMk id="48" creationId="{094E29AE-C474-3CCD-52C0-D085CCBD05CB}"/>
+          </ac:spMkLst>
+        </pc:spChg>
+        <pc:spChg chg="mod">
+          <ac:chgData name="Fatima Pillosu" userId="a6295d4dc9e22643" providerId="LiveId" clId="{87453732-75AC-4426-B5D3-B7C69C2D4F54}" dt="2026-01-26T17:07:00.887" v="159"/>
+          <ac:spMkLst>
+            <pc:docMk/>
+            <pc:sldMk cId="2922174619" sldId="256"/>
+            <ac:spMk id="55" creationId="{3041A462-13E8-E68B-ED83-34E69527A7C3}"/>
+          </ac:spMkLst>
+        </pc:spChg>
+        <pc:spChg chg="mod">
+          <ac:chgData name="Fatima Pillosu" userId="a6295d4dc9e22643" providerId="LiveId" clId="{87453732-75AC-4426-B5D3-B7C69C2D4F54}" dt="2026-01-26T17:07:00.887" v="159"/>
+          <ac:spMkLst>
+            <pc:docMk/>
+            <pc:sldMk cId="2922174619" sldId="256"/>
+            <ac:spMk id="56" creationId="{0ABB75E4-DC24-C31B-F4F0-D6035B2DC0CC}"/>
+          </ac:spMkLst>
+        </pc:spChg>
+        <pc:spChg chg="del">
+          <ac:chgData name="Fatima Pillosu" userId="a6295d4dc9e22643" providerId="LiveId" clId="{87453732-75AC-4426-B5D3-B7C69C2D4F54}" dt="2026-01-26T16:25:49.861" v="43" actId="21"/>
+          <ac:spMkLst>
+            <pc:docMk/>
+            <pc:sldMk cId="2922174619" sldId="256"/>
+            <ac:spMk id="88" creationId="{4FF56070-D238-C224-AA97-E058A81BE633}"/>
+          </ac:spMkLst>
+        </pc:spChg>
+        <pc:spChg chg="del">
+          <ac:chgData name="Fatima Pillosu" userId="a6295d4dc9e22643" providerId="LiveId" clId="{87453732-75AC-4426-B5D3-B7C69C2D4F54}" dt="2026-01-26T16:25:49.861" v="43" actId="21"/>
+          <ac:spMkLst>
+            <pc:docMk/>
+            <pc:sldMk cId="2922174619" sldId="256"/>
+            <ac:spMk id="92" creationId="{5EA3B3E5-BDE1-8300-691A-8B995A0278E4}"/>
+          </ac:spMkLst>
+        </pc:spChg>
+        <pc:spChg chg="del">
+          <ac:chgData name="Fatima Pillosu" userId="a6295d4dc9e22643" providerId="LiveId" clId="{87453732-75AC-4426-B5D3-B7C69C2D4F54}" dt="2026-01-26T16:25:49.861" v="43" actId="21"/>
+          <ac:spMkLst>
+            <pc:docMk/>
+            <pc:sldMk cId="2922174619" sldId="256"/>
+            <ac:spMk id="94" creationId="{A15B6D45-79F5-B9F8-C9E6-C2B4A302D2EA}"/>
+          </ac:spMkLst>
+        </pc:spChg>
+        <pc:spChg chg="del mod">
+          <ac:chgData name="Fatima Pillosu" userId="a6295d4dc9e22643" providerId="LiveId" clId="{87453732-75AC-4426-B5D3-B7C69C2D4F54}" dt="2026-01-26T16:25:49.861" v="43" actId="21"/>
+          <ac:spMkLst>
+            <pc:docMk/>
+            <pc:sldMk cId="2922174619" sldId="256"/>
+            <ac:spMk id="95" creationId="{C12DC1C5-1801-3D4B-2A03-DAB145A118F6}"/>
+          </ac:spMkLst>
+        </pc:spChg>
+        <pc:spChg chg="del">
+          <ac:chgData name="Fatima Pillosu" userId="a6295d4dc9e22643" providerId="LiveId" clId="{87453732-75AC-4426-B5D3-B7C69C2D4F54}" dt="2026-01-26T16:25:49.861" v="43" actId="21"/>
+          <ac:spMkLst>
+            <pc:docMk/>
+            <pc:sldMk cId="2922174619" sldId="256"/>
+            <ac:spMk id="102" creationId="{AEF2F405-62A6-9184-E2DA-F8586E4DAAA1}"/>
+          </ac:spMkLst>
+        </pc:spChg>
+        <pc:spChg chg="del">
+          <ac:chgData name="Fatima Pillosu" userId="a6295d4dc9e22643" providerId="LiveId" clId="{87453732-75AC-4426-B5D3-B7C69C2D4F54}" dt="2026-01-26T16:25:49.861" v="43" actId="21"/>
+          <ac:spMkLst>
+            <pc:docMk/>
+            <pc:sldMk cId="2922174619" sldId="256"/>
+            <ac:spMk id="103" creationId="{3AC1E00C-7CC8-E558-16F9-CBB16592A278}"/>
+          </ac:spMkLst>
+        </pc:spChg>
+        <pc:spChg chg="del">
+          <ac:chgData name="Fatima Pillosu" userId="a6295d4dc9e22643" providerId="LiveId" clId="{87453732-75AC-4426-B5D3-B7C69C2D4F54}" dt="2026-01-26T16:25:49.861" v="43" actId="21"/>
+          <ac:spMkLst>
+            <pc:docMk/>
+            <pc:sldMk cId="2922174619" sldId="256"/>
+            <ac:spMk id="104" creationId="{E2C60F2E-5AEC-FD98-E016-93A8494C37D8}"/>
+          </ac:spMkLst>
+        </pc:spChg>
+        <pc:spChg chg="del">
+          <ac:chgData name="Fatima Pillosu" userId="a6295d4dc9e22643" providerId="LiveId" clId="{87453732-75AC-4426-B5D3-B7C69C2D4F54}" dt="2026-01-26T16:25:49.861" v="43" actId="21"/>
+          <ac:spMkLst>
+            <pc:docMk/>
+            <pc:sldMk cId="2922174619" sldId="256"/>
+            <ac:spMk id="105" creationId="{094E29AE-C474-3CCD-52C0-D085CCBD05CB}"/>
+          </ac:spMkLst>
+        </pc:spChg>
+        <pc:spChg chg="del">
+          <ac:chgData name="Fatima Pillosu" userId="a6295d4dc9e22643" providerId="LiveId" clId="{87453732-75AC-4426-B5D3-B7C69C2D4F54}" dt="2026-01-26T16:25:49.861" v="43" actId="21"/>
+          <ac:spMkLst>
+            <pc:docMk/>
+            <pc:sldMk cId="2922174619" sldId="256"/>
+            <ac:spMk id="111" creationId="{3041A462-13E8-E68B-ED83-34E69527A7C3}"/>
+          </ac:spMkLst>
+        </pc:spChg>
+        <pc:spChg chg="del">
+          <ac:chgData name="Fatima Pillosu" userId="a6295d4dc9e22643" providerId="LiveId" clId="{87453732-75AC-4426-B5D3-B7C69C2D4F54}" dt="2026-01-26T16:25:49.861" v="43" actId="21"/>
+          <ac:spMkLst>
+            <pc:docMk/>
+            <pc:sldMk cId="2922174619" sldId="256"/>
+            <ac:spMk id="112" creationId="{0ABB75E4-DC24-C31B-F4F0-D6035B2DC0CC}"/>
+          </ac:spMkLst>
+        </pc:spChg>
+        <pc:grpChg chg="mod">
+          <ac:chgData name="Fatima Pillosu" userId="a6295d4dc9e22643" providerId="LiveId" clId="{87453732-75AC-4426-B5D3-B7C69C2D4F54}" dt="2026-01-26T16:30:22.010" v="153" actId="1036"/>
+          <ac:grpSpMkLst>
+            <pc:docMk/>
+            <pc:sldMk cId="2922174619" sldId="256"/>
+            <ac:grpSpMk id="3" creationId="{5BA45A38-88EB-09EC-D8FE-F556596A2A90}"/>
+          </ac:grpSpMkLst>
+        </pc:grpChg>
+        <pc:grpChg chg="mod">
+          <ac:chgData name="Fatima Pillosu" userId="a6295d4dc9e22643" providerId="LiveId" clId="{87453732-75AC-4426-B5D3-B7C69C2D4F54}" dt="2026-01-26T16:28:52.316" v="124" actId="1037"/>
+          <ac:grpSpMkLst>
+            <pc:docMk/>
+            <pc:sldMk cId="2922174619" sldId="256"/>
+            <ac:grpSpMk id="10" creationId="{87DBA8D6-574F-BFA7-7C61-9430A7E58D71}"/>
+          </ac:grpSpMkLst>
+        </pc:grpChg>
+        <pc:grpChg chg="del mod">
+          <ac:chgData name="Fatima Pillosu" userId="a6295d4dc9e22643" providerId="LiveId" clId="{87453732-75AC-4426-B5D3-B7C69C2D4F54}" dt="2026-01-26T17:06:51.446" v="158" actId="21"/>
+          <ac:grpSpMkLst>
+            <pc:docMk/>
+            <pc:sldMk cId="2922174619" sldId="256"/>
+            <ac:grpSpMk id="13" creationId="{00DC0CBC-1589-645C-A091-E3BCB3E252AB}"/>
+          </ac:grpSpMkLst>
+        </pc:grpChg>
+        <pc:grpChg chg="add del mod">
+          <ac:chgData name="Fatima Pillosu" userId="a6295d4dc9e22643" providerId="LiveId" clId="{87453732-75AC-4426-B5D3-B7C69C2D4F54}" dt="2026-01-26T17:06:51.446" v="158" actId="21"/>
+          <ac:grpSpMkLst>
+            <pc:docMk/>
+            <pc:sldMk cId="2922174619" sldId="256"/>
+            <ac:grpSpMk id="28" creationId="{75FFF979-52C9-D42D-37D8-AF2C6E84A00C}"/>
+          </ac:grpSpMkLst>
+        </pc:grpChg>
+        <pc:grpChg chg="mod">
+          <ac:chgData name="Fatima Pillosu" userId="a6295d4dc9e22643" providerId="LiveId" clId="{87453732-75AC-4426-B5D3-B7C69C2D4F54}" dt="2026-01-26T17:07:29.033" v="167" actId="164"/>
+          <ac:grpSpMkLst>
+            <pc:docMk/>
+            <pc:sldMk cId="2922174619" sldId="256"/>
+            <ac:grpSpMk id="39" creationId="{87DBA8D6-574F-BFA7-7C61-9430A7E58D71}"/>
+          </ac:grpSpMkLst>
+        </pc:grpChg>
+        <pc:grpChg chg="mod">
+          <ac:chgData name="Fatima Pillosu" userId="a6295d4dc9e22643" providerId="LiveId" clId="{87453732-75AC-4426-B5D3-B7C69C2D4F54}" dt="2026-01-26T17:07:07.451" v="166" actId="1036"/>
+          <ac:grpSpMkLst>
+            <pc:docMk/>
+            <pc:sldMk cId="2922174619" sldId="256"/>
+            <ac:grpSpMk id="42" creationId="{00DC0CBC-1589-645C-A091-E3BCB3E252AB}"/>
+          </ac:grpSpMkLst>
+        </pc:grpChg>
+        <pc:grpChg chg="mod">
+          <ac:chgData name="Fatima Pillosu" userId="a6295d4dc9e22643" providerId="LiveId" clId="{87453732-75AC-4426-B5D3-B7C69C2D4F54}" dt="2026-01-26T17:07:29.033" v="167" actId="164"/>
+          <ac:grpSpMkLst>
+            <pc:docMk/>
+            <pc:sldMk cId="2922174619" sldId="256"/>
+            <ac:grpSpMk id="53" creationId="{75FFF979-52C9-D42D-37D8-AF2C6E84A00C}"/>
+          </ac:grpSpMkLst>
+        </pc:grpChg>
+        <pc:grpChg chg="add mod">
+          <ac:chgData name="Fatima Pillosu" userId="a6295d4dc9e22643" providerId="LiveId" clId="{87453732-75AC-4426-B5D3-B7C69C2D4F54}" dt="2026-01-26T17:09:51.683" v="198" actId="1076"/>
+          <ac:grpSpMkLst>
+            <pc:docMk/>
+            <pc:sldMk cId="2922174619" sldId="256"/>
+            <ac:grpSpMk id="57" creationId="{806A4D48-4C4B-BE02-7232-A34354D237E1}"/>
+          </ac:grpSpMkLst>
+        </pc:grpChg>
+        <pc:picChg chg="mod">
+          <ac:chgData name="Fatima Pillosu" userId="a6295d4dc9e22643" providerId="LiveId" clId="{87453732-75AC-4426-B5D3-B7C69C2D4F54}" dt="2026-01-26T16:29:31.535" v="133" actId="1076"/>
+          <ac:picMkLst>
+            <pc:docMk/>
+            <pc:sldMk cId="2922174619" sldId="256"/>
+            <ac:picMk id="5" creationId="{9DB3C0CB-F121-AB89-6F90-0A67900A971C}"/>
+          </ac:picMkLst>
+        </pc:picChg>
+        <pc:picChg chg="mod">
+          <ac:chgData name="Fatima Pillosu" userId="a6295d4dc9e22643" providerId="LiveId" clId="{87453732-75AC-4426-B5D3-B7C69C2D4F54}" dt="2026-01-26T16:29:55.350" v="137" actId="1076"/>
+          <ac:picMkLst>
+            <pc:docMk/>
+            <pc:sldMk cId="2922174619" sldId="256"/>
+            <ac:picMk id="20" creationId="{BE52EE0A-1373-B866-C4C7-77A5B2CBCBC8}"/>
+          </ac:picMkLst>
+        </pc:picChg>
+        <pc:picChg chg="mod">
+          <ac:chgData name="Fatima Pillosu" userId="a6295d4dc9e22643" providerId="LiveId" clId="{87453732-75AC-4426-B5D3-B7C69C2D4F54}" dt="2026-01-26T17:10:14.692" v="203" actId="1076"/>
+          <ac:picMkLst>
+            <pc:docMk/>
+            <pc:sldMk cId="2922174619" sldId="256"/>
+            <ac:picMk id="34" creationId="{9DB3C0CB-F121-AB89-6F90-0A67900A971C}"/>
+          </ac:picMkLst>
+        </pc:picChg>
+        <pc:cxnChg chg="mod">
+          <ac:chgData name="Fatima Pillosu" userId="a6295d4dc9e22643" providerId="LiveId" clId="{87453732-75AC-4426-B5D3-B7C69C2D4F54}" dt="2026-01-26T16:28:45.725" v="123" actId="12788"/>
+          <ac:cxnSpMkLst>
+            <pc:docMk/>
+            <pc:sldMk cId="2922174619" sldId="256"/>
+            <ac:cxnSpMk id="7" creationId="{994F828A-EEDA-8FF4-1317-E8AF2D093D97}"/>
+          </ac:cxnSpMkLst>
+        </pc:cxnChg>
+        <pc:cxnChg chg="mod">
+          <ac:chgData name="Fatima Pillosu" userId="a6295d4dc9e22643" providerId="LiveId" clId="{87453732-75AC-4426-B5D3-B7C69C2D4F54}" dt="2026-01-26T16:27:48.307" v="115" actId="1076"/>
+          <ac:cxnSpMkLst>
+            <pc:docMk/>
+            <pc:sldMk cId="2922174619" sldId="256"/>
+            <ac:cxnSpMk id="21" creationId="{7D935352-A1CB-CD98-5B07-68B96108C511}"/>
+          </ac:cxnSpMkLst>
+        </pc:cxnChg>
+        <pc:cxnChg chg="mod">
+          <ac:chgData name="Fatima Pillosu" userId="a6295d4dc9e22643" providerId="LiveId" clId="{87453732-75AC-4426-B5D3-B7C69C2D4F54}" dt="2026-01-26T16:28:58.952" v="126" actId="1035"/>
+          <ac:cxnSpMkLst>
+            <pc:docMk/>
+            <pc:sldMk cId="2922174619" sldId="256"/>
+            <ac:cxnSpMk id="22" creationId="{88DFB1B9-2D33-4164-D9A3-A66D31087C2A}"/>
+          </ac:cxnSpMkLst>
+        </pc:cxnChg>
+        <pc:cxnChg chg="mod">
+          <ac:chgData name="Fatima Pillosu" userId="a6295d4dc9e22643" providerId="LiveId" clId="{87453732-75AC-4426-B5D3-B7C69C2D4F54}" dt="2026-01-26T16:28:52.316" v="124" actId="1037"/>
+          <ac:cxnSpMkLst>
+            <pc:docMk/>
+            <pc:sldMk cId="2922174619" sldId="256"/>
+            <ac:cxnSpMk id="23" creationId="{858CED55-193B-AED5-D807-6ACCF9F7F9B2}"/>
+          </ac:cxnSpMkLst>
+        </pc:cxnChg>
+        <pc:cxnChg chg="mod">
+          <ac:chgData name="Fatima Pillosu" userId="a6295d4dc9e22643" providerId="LiveId" clId="{87453732-75AC-4426-B5D3-B7C69C2D4F54}" dt="2026-01-26T16:28:52.316" v="124" actId="1037"/>
+          <ac:cxnSpMkLst>
+            <pc:docMk/>
+            <pc:sldMk cId="2922174619" sldId="256"/>
+            <ac:cxnSpMk id="24" creationId="{81AA77C9-2BA6-9449-258D-DEDF65B8D8A9}"/>
+          </ac:cxnSpMkLst>
+        </pc:cxnChg>
+      </pc:sldChg>
+    </pc:docChg>
+  </pc:docChgLst>
+</pc:chgInfo>
 </file>
 
 <file path=ppt/slideLayouts/slideLayout1.xml><?xml version="1.0" encoding="utf-8"?>
@@ -136,8 +570,8 @@
         </p:nvSpPr>
         <p:spPr>
           <a:xfrm>
-            <a:off x="310515" y="748242"/>
-            <a:ext cx="3519170" cy="1591733"/>
+            <a:off x="310515" y="706933"/>
+            <a:ext cx="3519170" cy="1503857"/>
           </a:xfrm>
         </p:spPr>
         <p:txBody>
@@ -168,8 +602,8 @@
         </p:nvSpPr>
         <p:spPr>
           <a:xfrm>
-            <a:off x="517525" y="2401359"/>
-            <a:ext cx="3105150" cy="1103841"/>
+            <a:off x="517525" y="2268784"/>
+            <a:ext cx="3105150" cy="1042900"/>
           </a:xfrm>
         </p:spPr>
         <p:txBody>
@@ -238,7 +672,7 @@
           <a:p>
             <a:fld id="{AB990FC2-CCE9-4CA4-B1F5-E0AE66462007}" type="datetimeFigureOut">
               <a:rPr lang="it-IT" smtClean="0"/>
-              <a:t>22/01/2026</a:t>
+              <a:t>26/01/2026</a:t>
             </a:fld>
             <a:endParaRPr lang="it-IT"/>
           </a:p>
@@ -289,7 +723,7 @@
     </p:spTree>
     <p:extLst>
       <p:ext uri="{BB962C8B-B14F-4D97-AF65-F5344CB8AC3E}">
-        <p14:creationId xmlns:p14="http://schemas.microsoft.com/office/powerpoint/2010/main" val="1071253304"/>
+        <p14:creationId xmlns:p14="http://schemas.microsoft.com/office/powerpoint/2010/main" val="2277928405"/>
       </p:ext>
     </p:extLst>
   </p:cSld>
@@ -408,7 +842,7 @@
           <a:p>
             <a:fld id="{AB990FC2-CCE9-4CA4-B1F5-E0AE66462007}" type="datetimeFigureOut">
               <a:rPr lang="it-IT" smtClean="0"/>
-              <a:t>22/01/2026</a:t>
+              <a:t>26/01/2026</a:t>
             </a:fld>
             <a:endParaRPr lang="it-IT"/>
           </a:p>
@@ -459,7 +893,7 @@
     </p:spTree>
     <p:extLst>
       <p:ext uri="{BB962C8B-B14F-4D97-AF65-F5344CB8AC3E}">
-        <p14:creationId xmlns:p14="http://schemas.microsoft.com/office/powerpoint/2010/main" val="1598635047"/>
+        <p14:creationId xmlns:p14="http://schemas.microsoft.com/office/powerpoint/2010/main" val="2517028599"/>
       </p:ext>
     </p:extLst>
   </p:cSld>
@@ -498,8 +932,8 @@
         </p:nvSpPr>
         <p:spPr>
           <a:xfrm>
-            <a:off x="2962831" y="243417"/>
-            <a:ext cx="892731" cy="3874559"/>
+            <a:off x="2962831" y="229978"/>
+            <a:ext cx="892731" cy="3660651"/>
           </a:xfrm>
         </p:spPr>
         <p:txBody>
@@ -526,8 +960,8 @@
         </p:nvSpPr>
         <p:spPr>
           <a:xfrm>
-            <a:off x="284639" y="243417"/>
-            <a:ext cx="2626439" cy="3874559"/>
+            <a:off x="284639" y="229978"/>
+            <a:ext cx="2626439" cy="3660651"/>
           </a:xfrm>
         </p:spPr>
         <p:txBody>
@@ -588,7 +1022,7 @@
           <a:p>
             <a:fld id="{AB990FC2-CCE9-4CA4-B1F5-E0AE66462007}" type="datetimeFigureOut">
               <a:rPr lang="it-IT" smtClean="0"/>
-              <a:t>22/01/2026</a:t>
+              <a:t>26/01/2026</a:t>
             </a:fld>
             <a:endParaRPr lang="it-IT"/>
           </a:p>
@@ -639,7 +1073,7 @@
     </p:spTree>
     <p:extLst>
       <p:ext uri="{BB962C8B-B14F-4D97-AF65-F5344CB8AC3E}">
-        <p14:creationId xmlns:p14="http://schemas.microsoft.com/office/powerpoint/2010/main" val="725927585"/>
+        <p14:creationId xmlns:p14="http://schemas.microsoft.com/office/powerpoint/2010/main" val="2293432225"/>
       </p:ext>
     </p:extLst>
   </p:cSld>
@@ -758,7 +1192,7 @@
           <a:p>
             <a:fld id="{AB990FC2-CCE9-4CA4-B1F5-E0AE66462007}" type="datetimeFigureOut">
               <a:rPr lang="it-IT" smtClean="0"/>
-              <a:t>22/01/2026</a:t>
+              <a:t>26/01/2026</a:t>
             </a:fld>
             <a:endParaRPr lang="it-IT"/>
           </a:p>
@@ -809,7 +1243,7 @@
     </p:spTree>
     <p:extLst>
       <p:ext uri="{BB962C8B-B14F-4D97-AF65-F5344CB8AC3E}">
-        <p14:creationId xmlns:p14="http://schemas.microsoft.com/office/powerpoint/2010/main" val="3314604851"/>
+        <p14:creationId xmlns:p14="http://schemas.microsoft.com/office/powerpoint/2010/main" val="3695549396"/>
       </p:ext>
     </p:extLst>
   </p:cSld>
@@ -848,8 +1282,8 @@
         </p:nvSpPr>
         <p:spPr>
           <a:xfrm>
-            <a:off x="282482" y="1139826"/>
-            <a:ext cx="3570923" cy="1901825"/>
+            <a:off x="282482" y="1076899"/>
+            <a:ext cx="3570923" cy="1796828"/>
           </a:xfrm>
         </p:spPr>
         <p:txBody>
@@ -880,8 +1314,8 @@
         </p:nvSpPr>
         <p:spPr>
           <a:xfrm>
-            <a:off x="282482" y="3059643"/>
-            <a:ext cx="3570923" cy="1000125"/>
+            <a:off x="282482" y="2890725"/>
+            <a:ext cx="3570923" cy="944910"/>
           </a:xfrm>
         </p:spPr>
         <p:txBody>
@@ -1004,7 +1438,7 @@
           <a:p>
             <a:fld id="{AB990FC2-CCE9-4CA4-B1F5-E0AE66462007}" type="datetimeFigureOut">
               <a:rPr lang="it-IT" smtClean="0"/>
-              <a:t>22/01/2026</a:t>
+              <a:t>26/01/2026</a:t>
             </a:fld>
             <a:endParaRPr lang="it-IT"/>
           </a:p>
@@ -1055,7 +1489,7 @@
     </p:spTree>
     <p:extLst>
       <p:ext uri="{BB962C8B-B14F-4D97-AF65-F5344CB8AC3E}">
-        <p14:creationId xmlns:p14="http://schemas.microsoft.com/office/powerpoint/2010/main" val="2366214472"/>
+        <p14:creationId xmlns:p14="http://schemas.microsoft.com/office/powerpoint/2010/main" val="3196843502"/>
       </p:ext>
     </p:extLst>
   </p:cSld>
@@ -1117,8 +1551,8 @@
         </p:nvSpPr>
         <p:spPr>
           <a:xfrm>
-            <a:off x="284639" y="1217083"/>
-            <a:ext cx="1759585" cy="2900892"/>
+            <a:off x="284639" y="1149890"/>
+            <a:ext cx="1759585" cy="2740739"/>
           </a:xfrm>
         </p:spPr>
         <p:txBody>
@@ -1174,8 +1608,8 @@
         </p:nvSpPr>
         <p:spPr>
           <a:xfrm>
-            <a:off x="2095976" y="1217083"/>
-            <a:ext cx="1759585" cy="2900892"/>
+            <a:off x="2095976" y="1149890"/>
+            <a:ext cx="1759585" cy="2740739"/>
           </a:xfrm>
         </p:spPr>
         <p:txBody>
@@ -1236,7 +1670,7 @@
           <a:p>
             <a:fld id="{AB990FC2-CCE9-4CA4-B1F5-E0AE66462007}" type="datetimeFigureOut">
               <a:rPr lang="it-IT" smtClean="0"/>
-              <a:t>22/01/2026</a:t>
+              <a:t>26/01/2026</a:t>
             </a:fld>
             <a:endParaRPr lang="it-IT"/>
           </a:p>
@@ -1287,7 +1721,7 @@
     </p:spTree>
     <p:extLst>
       <p:ext uri="{BB962C8B-B14F-4D97-AF65-F5344CB8AC3E}">
-        <p14:creationId xmlns:p14="http://schemas.microsoft.com/office/powerpoint/2010/main" val="2107258722"/>
+        <p14:creationId xmlns:p14="http://schemas.microsoft.com/office/powerpoint/2010/main" val="3462235140"/>
       </p:ext>
     </p:extLst>
   </p:cSld>
@@ -1326,8 +1760,8 @@
         </p:nvSpPr>
         <p:spPr>
           <a:xfrm>
-            <a:off x="285178" y="243418"/>
-            <a:ext cx="3570923" cy="883709"/>
+            <a:off x="285178" y="229979"/>
+            <a:ext cx="3570923" cy="834921"/>
           </a:xfrm>
         </p:spPr>
         <p:txBody>
@@ -1354,8 +1788,8 @@
         </p:nvSpPr>
         <p:spPr>
           <a:xfrm>
-            <a:off x="285179" y="1120775"/>
-            <a:ext cx="1751498" cy="549275"/>
+            <a:off x="285179" y="1058899"/>
+            <a:ext cx="1751498" cy="518950"/>
           </a:xfrm>
         </p:spPr>
         <p:txBody>
@@ -1419,8 +1853,8 @@
         </p:nvSpPr>
         <p:spPr>
           <a:xfrm>
-            <a:off x="285179" y="1670050"/>
-            <a:ext cx="1751498" cy="2456392"/>
+            <a:off x="285179" y="1577849"/>
+            <a:ext cx="1751498" cy="2320779"/>
           </a:xfrm>
         </p:spPr>
         <p:txBody>
@@ -1476,8 +1910,8 @@
         </p:nvSpPr>
         <p:spPr>
           <a:xfrm>
-            <a:off x="2095977" y="1120775"/>
-            <a:ext cx="1760124" cy="549275"/>
+            <a:off x="2095977" y="1058899"/>
+            <a:ext cx="1760124" cy="518950"/>
           </a:xfrm>
         </p:spPr>
         <p:txBody>
@@ -1541,8 +1975,8 @@
         </p:nvSpPr>
         <p:spPr>
           <a:xfrm>
-            <a:off x="2095977" y="1670050"/>
-            <a:ext cx="1760124" cy="2456392"/>
+            <a:off x="2095977" y="1577849"/>
+            <a:ext cx="1760124" cy="2320779"/>
           </a:xfrm>
         </p:spPr>
         <p:txBody>
@@ -1603,7 +2037,7 @@
           <a:p>
             <a:fld id="{AB990FC2-CCE9-4CA4-B1F5-E0AE66462007}" type="datetimeFigureOut">
               <a:rPr lang="it-IT" smtClean="0"/>
-              <a:t>22/01/2026</a:t>
+              <a:t>26/01/2026</a:t>
             </a:fld>
             <a:endParaRPr lang="it-IT"/>
           </a:p>
@@ -1654,7 +2088,7 @@
     </p:spTree>
     <p:extLst>
       <p:ext uri="{BB962C8B-B14F-4D97-AF65-F5344CB8AC3E}">
-        <p14:creationId xmlns:p14="http://schemas.microsoft.com/office/powerpoint/2010/main" val="2002887369"/>
+        <p14:creationId xmlns:p14="http://schemas.microsoft.com/office/powerpoint/2010/main" val="244360731"/>
       </p:ext>
     </p:extLst>
   </p:cSld>
@@ -1721,7 +2155,7 @@
           <a:p>
             <a:fld id="{AB990FC2-CCE9-4CA4-B1F5-E0AE66462007}" type="datetimeFigureOut">
               <a:rPr lang="it-IT" smtClean="0"/>
-              <a:t>22/01/2026</a:t>
+              <a:t>26/01/2026</a:t>
             </a:fld>
             <a:endParaRPr lang="it-IT"/>
           </a:p>
@@ -1772,7 +2206,7 @@
     </p:spTree>
     <p:extLst>
       <p:ext uri="{BB962C8B-B14F-4D97-AF65-F5344CB8AC3E}">
-        <p14:creationId xmlns:p14="http://schemas.microsoft.com/office/powerpoint/2010/main" val="2860037162"/>
+        <p14:creationId xmlns:p14="http://schemas.microsoft.com/office/powerpoint/2010/main" val="301857791"/>
       </p:ext>
     </p:extLst>
   </p:cSld>
@@ -1816,7 +2250,7 @@
           <a:p>
             <a:fld id="{AB990FC2-CCE9-4CA4-B1F5-E0AE66462007}" type="datetimeFigureOut">
               <a:rPr lang="it-IT" smtClean="0"/>
-              <a:t>22/01/2026</a:t>
+              <a:t>26/01/2026</a:t>
             </a:fld>
             <a:endParaRPr lang="it-IT"/>
           </a:p>
@@ -1867,7 +2301,7 @@
     </p:spTree>
     <p:extLst>
       <p:ext uri="{BB962C8B-B14F-4D97-AF65-F5344CB8AC3E}">
-        <p14:creationId xmlns:p14="http://schemas.microsoft.com/office/powerpoint/2010/main" val="3423355307"/>
+        <p14:creationId xmlns:p14="http://schemas.microsoft.com/office/powerpoint/2010/main" val="4183798690"/>
       </p:ext>
     </p:extLst>
   </p:cSld>
@@ -1906,8 +2340,8 @@
         </p:nvSpPr>
         <p:spPr>
           <a:xfrm>
-            <a:off x="285178" y="304800"/>
-            <a:ext cx="1335322" cy="1066800"/>
+            <a:off x="285178" y="287972"/>
+            <a:ext cx="1335322" cy="1007904"/>
           </a:xfrm>
         </p:spPr>
         <p:txBody>
@@ -1938,8 +2372,8 @@
         </p:nvSpPr>
         <p:spPr>
           <a:xfrm>
-            <a:off x="1760124" y="658285"/>
-            <a:ext cx="2095976" cy="3249083"/>
+            <a:off x="1760124" y="621942"/>
+            <a:ext cx="2095976" cy="3069707"/>
           </a:xfrm>
         </p:spPr>
         <p:txBody>
@@ -2023,8 +2457,8 @@
         </p:nvSpPr>
         <p:spPr>
           <a:xfrm>
-            <a:off x="285178" y="1371600"/>
-            <a:ext cx="1335322" cy="2541059"/>
+            <a:off x="285178" y="1295877"/>
+            <a:ext cx="1335322" cy="2400771"/>
           </a:xfrm>
         </p:spPr>
         <p:txBody>
@@ -2093,7 +2527,7 @@
           <a:p>
             <a:fld id="{AB990FC2-CCE9-4CA4-B1F5-E0AE66462007}" type="datetimeFigureOut">
               <a:rPr lang="it-IT" smtClean="0"/>
-              <a:t>22/01/2026</a:t>
+              <a:t>26/01/2026</a:t>
             </a:fld>
             <a:endParaRPr lang="it-IT"/>
           </a:p>
@@ -2144,7 +2578,7 @@
     </p:spTree>
     <p:extLst>
       <p:ext uri="{BB962C8B-B14F-4D97-AF65-F5344CB8AC3E}">
-        <p14:creationId xmlns:p14="http://schemas.microsoft.com/office/powerpoint/2010/main" val="2208432252"/>
+        <p14:creationId xmlns:p14="http://schemas.microsoft.com/office/powerpoint/2010/main" val="1353115806"/>
       </p:ext>
     </p:extLst>
   </p:cSld>
@@ -2183,8 +2617,8 @@
         </p:nvSpPr>
         <p:spPr>
           <a:xfrm>
-            <a:off x="285178" y="304800"/>
-            <a:ext cx="1335322" cy="1066800"/>
+            <a:off x="285178" y="287972"/>
+            <a:ext cx="1335322" cy="1007904"/>
           </a:xfrm>
         </p:spPr>
         <p:txBody>
@@ -2215,8 +2649,8 @@
         </p:nvSpPr>
         <p:spPr>
           <a:xfrm>
-            <a:off x="1760124" y="658285"/>
-            <a:ext cx="2095976" cy="3249083"/>
+            <a:off x="1760124" y="621942"/>
+            <a:ext cx="2095976" cy="3069707"/>
           </a:xfrm>
         </p:spPr>
         <p:txBody>
@@ -2280,8 +2714,8 @@
         </p:nvSpPr>
         <p:spPr>
           <a:xfrm>
-            <a:off x="285178" y="1371600"/>
-            <a:ext cx="1335322" cy="2541059"/>
+            <a:off x="285178" y="1295877"/>
+            <a:ext cx="1335322" cy="2400771"/>
           </a:xfrm>
         </p:spPr>
         <p:txBody>
@@ -2350,7 +2784,7 @@
           <a:p>
             <a:fld id="{AB990FC2-CCE9-4CA4-B1F5-E0AE66462007}" type="datetimeFigureOut">
               <a:rPr lang="it-IT" smtClean="0"/>
-              <a:t>22/01/2026</a:t>
+              <a:t>26/01/2026</a:t>
             </a:fld>
             <a:endParaRPr lang="it-IT"/>
           </a:p>
@@ -2401,7 +2835,7 @@
     </p:spTree>
     <p:extLst>
       <p:ext uri="{BB962C8B-B14F-4D97-AF65-F5344CB8AC3E}">
-        <p14:creationId xmlns:p14="http://schemas.microsoft.com/office/powerpoint/2010/main" val="1415990094"/>
+        <p14:creationId xmlns:p14="http://schemas.microsoft.com/office/powerpoint/2010/main" val="1656422846"/>
       </p:ext>
     </p:extLst>
   </p:cSld>
@@ -2445,8 +2879,8 @@
         </p:nvSpPr>
         <p:spPr>
           <a:xfrm>
-            <a:off x="284639" y="243418"/>
-            <a:ext cx="3570923" cy="883709"/>
+            <a:off x="284639" y="229979"/>
+            <a:ext cx="3570923" cy="834921"/>
           </a:xfrm>
           <a:prstGeom prst="rect">
             <a:avLst/>
@@ -2478,8 +2912,8 @@
         </p:nvSpPr>
         <p:spPr>
           <a:xfrm>
-            <a:off x="284639" y="1217083"/>
-            <a:ext cx="3570923" cy="2900892"/>
+            <a:off x="284639" y="1149890"/>
+            <a:ext cx="3570923" cy="2740739"/>
           </a:xfrm>
           <a:prstGeom prst="rect">
             <a:avLst/>
@@ -2540,8 +2974,8 @@
         </p:nvSpPr>
         <p:spPr>
           <a:xfrm>
-            <a:off x="284639" y="4237568"/>
-            <a:ext cx="931545" cy="243417"/>
+            <a:off x="284639" y="4003619"/>
+            <a:ext cx="931545" cy="229978"/>
           </a:xfrm>
           <a:prstGeom prst="rect">
             <a:avLst/>
@@ -2563,7 +2997,7 @@
           <a:p>
             <a:fld id="{AB990FC2-CCE9-4CA4-B1F5-E0AE66462007}" type="datetimeFigureOut">
               <a:rPr lang="it-IT" smtClean="0"/>
-              <a:t>22/01/2026</a:t>
+              <a:t>26/01/2026</a:t>
             </a:fld>
             <a:endParaRPr lang="it-IT"/>
           </a:p>
@@ -2581,8 +3015,8 @@
         </p:nvSpPr>
         <p:spPr>
           <a:xfrm>
-            <a:off x="1371441" y="4237568"/>
-            <a:ext cx="1397318" cy="243417"/>
+            <a:off x="1371441" y="4003619"/>
+            <a:ext cx="1397318" cy="229978"/>
           </a:xfrm>
           <a:prstGeom prst="rect">
             <a:avLst/>
@@ -2618,8 +3052,8 @@
         </p:nvSpPr>
         <p:spPr>
           <a:xfrm>
-            <a:off x="2924016" y="4237568"/>
-            <a:ext cx="931545" cy="243417"/>
+            <a:off x="2924016" y="4003619"/>
+            <a:ext cx="931545" cy="229978"/>
           </a:xfrm>
           <a:prstGeom prst="rect">
             <a:avLst/>
@@ -2650,23 +3084,23 @@
     </p:spTree>
     <p:extLst>
       <p:ext uri="{BB962C8B-B14F-4D97-AF65-F5344CB8AC3E}">
-        <p14:creationId xmlns:p14="http://schemas.microsoft.com/office/powerpoint/2010/main" val="3206456754"/>
+        <p14:creationId xmlns:p14="http://schemas.microsoft.com/office/powerpoint/2010/main" val="3059656814"/>
       </p:ext>
     </p:extLst>
   </p:cSld>
   <p:clrMap bg1="lt1" tx1="dk1" bg2="lt2" tx2="dk2" accent1="accent1" accent2="accent2" accent3="accent3" accent4="accent4" accent5="accent5" accent6="accent6" hlink="hlink" folHlink="folHlink"/>
   <p:sldLayoutIdLst>
-    <p:sldLayoutId id="2147483697" r:id="rId1"/>
-    <p:sldLayoutId id="2147483698" r:id="rId2"/>
-    <p:sldLayoutId id="2147483699" r:id="rId3"/>
-    <p:sldLayoutId id="2147483700" r:id="rId4"/>
-    <p:sldLayoutId id="2147483701" r:id="rId5"/>
-    <p:sldLayoutId id="2147483702" r:id="rId6"/>
-    <p:sldLayoutId id="2147483703" r:id="rId7"/>
-    <p:sldLayoutId id="2147483704" r:id="rId8"/>
-    <p:sldLayoutId id="2147483705" r:id="rId9"/>
-    <p:sldLayoutId id="2147483706" r:id="rId10"/>
-    <p:sldLayoutId id="2147483707" r:id="rId11"/>
+    <p:sldLayoutId id="2147483721" r:id="rId1"/>
+    <p:sldLayoutId id="2147483722" r:id="rId2"/>
+    <p:sldLayoutId id="2147483723" r:id="rId3"/>
+    <p:sldLayoutId id="2147483724" r:id="rId4"/>
+    <p:sldLayoutId id="2147483725" r:id="rId5"/>
+    <p:sldLayoutId id="2147483726" r:id="rId6"/>
+    <p:sldLayoutId id="2147483727" r:id="rId7"/>
+    <p:sldLayoutId id="2147483728" r:id="rId8"/>
+    <p:sldLayoutId id="2147483729" r:id="rId9"/>
+    <p:sldLayoutId id="2147483730" r:id="rId10"/>
+    <p:sldLayoutId id="2147483731" r:id="rId11"/>
   </p:sldLayoutIdLst>
   <p:txStyles>
     <p:titleStyle>
@@ -2970,7 +3404,7 @@
       </p:grpSpPr>
       <p:sp>
         <p:nvSpPr>
-          <p:cNvPr id="88" name="TextBox 87">
+          <p:cNvPr id="31" name="TextBox 30">
             <a:extLst>
               <a:ext uri="{FF2B5EF4-FFF2-40B4-BE49-F238E27FC236}">
                 <a16:creationId xmlns:a16="http://schemas.microsoft.com/office/drawing/2014/main" id="{4FF56070-D238-C224-AA97-E058A81BE633}"/>
@@ -2983,7 +3417,7 @@
         <p:spPr>
           <a:xfrm>
             <a:off x="-83152" y="-65388"/>
-            <a:ext cx="4206875" cy="430887"/>
+            <a:ext cx="4206875" cy="400110"/>
           </a:xfrm>
           <a:prstGeom prst="rect">
             <a:avLst/>
@@ -2997,7 +3431,7 @@
           <a:lstStyle/>
           <a:p>
             <a:r>
-              <a:rPr lang="en-US" sz="1200" b="1" dirty="0">
+              <a:rPr lang="en-US" sz="1000" b="1" dirty="0">
                 <a:solidFill>
                   <a:srgbClr val="333333"/>
                 </a:solidFill>
@@ -3030,10 +3464,10 @@
       </p:sp>
       <p:grpSp>
         <p:nvGrpSpPr>
-          <p:cNvPr id="89" name="Group 88">
+          <p:cNvPr id="57" name="Group 56">
             <a:extLst>
               <a:ext uri="{FF2B5EF4-FFF2-40B4-BE49-F238E27FC236}">
-                <a16:creationId xmlns:a16="http://schemas.microsoft.com/office/drawing/2014/main" id="{5BA45A38-88EB-09EC-D8FE-F556596A2A90}"/>
+                <a16:creationId xmlns:a16="http://schemas.microsoft.com/office/drawing/2014/main" id="{806A4D48-4C4B-BE02-7232-A34354D237E1}"/>
               </a:ext>
             </a:extLst>
           </p:cNvPr>
@@ -3042,18 +3476,297 @@
         </p:nvGrpSpPr>
         <p:grpSpPr>
           <a:xfrm>
-            <a:off x="1071391" y="419648"/>
-            <a:ext cx="1927275" cy="553998"/>
-            <a:chOff x="1262387" y="701588"/>
-            <a:chExt cx="1927275" cy="553998"/>
+            <a:off x="143431" y="322228"/>
+            <a:ext cx="3853338" cy="3969145"/>
+            <a:chOff x="102029" y="303178"/>
+            <a:chExt cx="3853338" cy="3969145"/>
           </a:xfrm>
         </p:grpSpPr>
+        <p:grpSp>
+          <p:nvGrpSpPr>
+            <p:cNvPr id="32" name="Group 31">
+              <a:extLst>
+                <a:ext uri="{FF2B5EF4-FFF2-40B4-BE49-F238E27FC236}">
+                  <a16:creationId xmlns:a16="http://schemas.microsoft.com/office/drawing/2014/main" id="{5BA45A38-88EB-09EC-D8FE-F556596A2A90}"/>
+                </a:ext>
+              </a:extLst>
+            </p:cNvPr>
+            <p:cNvGrpSpPr/>
+            <p:nvPr/>
+          </p:nvGrpSpPr>
+          <p:grpSpPr>
+            <a:xfrm>
+              <a:off x="1156284" y="303178"/>
+              <a:ext cx="1862690" cy="584775"/>
+              <a:chOff x="1347280" y="681426"/>
+              <a:chExt cx="1862690" cy="584775"/>
+            </a:xfrm>
+          </p:grpSpPr>
+          <p:sp>
+            <p:nvSpPr>
+              <p:cNvPr id="33" name="TextBox 32">
+                <a:extLst>
+                  <a:ext uri="{FF2B5EF4-FFF2-40B4-BE49-F238E27FC236}">
+                    <a16:creationId xmlns:a16="http://schemas.microsoft.com/office/drawing/2014/main" id="{0BB2AAB9-265F-B714-DBA2-FF13C3B6D595}"/>
+                  </a:ext>
+                </a:extLst>
+              </p:cNvPr>
+              <p:cNvSpPr txBox="1"/>
+              <p:nvPr/>
+            </p:nvSpPr>
+            <p:spPr>
+              <a:xfrm>
+                <a:off x="1945861" y="681426"/>
+                <a:ext cx="1264109" cy="584775"/>
+              </a:xfrm>
+              <a:prstGeom prst="rect">
+                <a:avLst/>
+              </a:prstGeom>
+              <a:noFill/>
+              <a:ln w="3175">
+                <a:noFill/>
+              </a:ln>
+            </p:spPr>
+            <p:txBody>
+              <a:bodyPr wrap="square" rtlCol="0">
+                <a:spAutoFit/>
+              </a:bodyPr>
+              <a:lstStyle/>
+              <a:p>
+                <a:pPr algn="ctr"/>
+                <a:r>
+                  <a:rPr lang="en-US" sz="800" dirty="0">
+                    <a:solidFill>
+                      <a:srgbClr val="333333"/>
+                    </a:solidFill>
+                    <a:latin typeface="Calibri Light" panose="020F0302020204030204" pitchFamily="34" charset="0"/>
+                    <a:cs typeface="Calibri Light" panose="020F0302020204030204" pitchFamily="34" charset="0"/>
+                  </a:rPr>
+                  <a:t>ERA5-ecPoint</a:t>
+                </a:r>
+              </a:p>
+              <a:p>
+                <a:pPr algn="ctr"/>
+                <a:r>
+                  <a:rPr lang="en-US" sz="800" dirty="0">
+                    <a:solidFill>
+                      <a:srgbClr val="333333"/>
+                    </a:solidFill>
+                    <a:latin typeface="Calibri Light" panose="020F0302020204030204" pitchFamily="34" charset="0"/>
+                    <a:cs typeface="Calibri Light" panose="020F0302020204030204" pitchFamily="34" charset="0"/>
+                  </a:rPr>
+                  <a:t>rainfall forecasts</a:t>
+                </a:r>
+              </a:p>
+              <a:p>
+                <a:pPr algn="ctr"/>
+                <a:r>
+                  <a:rPr lang="en-US" sz="800" dirty="0">
+                    <a:solidFill>
+                      <a:srgbClr val="333333"/>
+                    </a:solidFill>
+                    <a:latin typeface="Calibri Light" panose="020F0302020204030204" pitchFamily="34" charset="0"/>
+                    <a:cs typeface="Calibri Light" panose="020F0302020204030204" pitchFamily="34" charset="0"/>
+                  </a:rPr>
+                  <a:t>(mm/24h, point-scale within the grid-box)</a:t>
+                </a:r>
+              </a:p>
+            </p:txBody>
+          </p:sp>
+          <p:pic>
+            <p:nvPicPr>
+              <p:cNvPr id="34" name="Picture 33">
+                <a:extLst>
+                  <a:ext uri="{FF2B5EF4-FFF2-40B4-BE49-F238E27FC236}">
+                    <a16:creationId xmlns:a16="http://schemas.microsoft.com/office/drawing/2014/main" id="{9DB3C0CB-F121-AB89-6F90-0A67900A971C}"/>
+                  </a:ext>
+                </a:extLst>
+              </p:cNvPr>
+              <p:cNvPicPr>
+                <a:picLocks noChangeAspect="1"/>
+              </p:cNvPicPr>
+              <p:nvPr/>
+            </p:nvPicPr>
+            <p:blipFill>
+              <a:blip r:embed="rId2"/>
+              <a:stretch>
+                <a:fillRect/>
+              </a:stretch>
+            </p:blipFill>
+            <p:spPr>
+              <a:xfrm>
+                <a:off x="1347280" y="697168"/>
+                <a:ext cx="630000" cy="540000"/>
+              </a:xfrm>
+              <a:prstGeom prst="rect">
+                <a:avLst/>
+              </a:prstGeom>
+            </p:spPr>
+          </p:pic>
+        </p:grpSp>
         <p:sp>
           <p:nvSpPr>
-            <p:cNvPr id="90" name="TextBox 89">
+            <p:cNvPr id="35" name="Rectangle 34">
               <a:extLst>
                 <a:ext uri="{FF2B5EF4-FFF2-40B4-BE49-F238E27FC236}">
-                  <a16:creationId xmlns:a16="http://schemas.microsoft.com/office/drawing/2014/main" id="{0BB2AAB9-265F-B714-DBA2-FF13C3B6D595}"/>
+                  <a16:creationId xmlns:a16="http://schemas.microsoft.com/office/drawing/2014/main" id="{5EA3B3E5-BDE1-8300-691A-8B995A0278E4}"/>
+                </a:ext>
+              </a:extLst>
+            </p:cNvPr>
+            <p:cNvSpPr/>
+            <p:nvPr/>
+          </p:nvSpPr>
+          <p:spPr>
+            <a:xfrm>
+              <a:off x="1021577" y="323340"/>
+              <a:ext cx="1997417" cy="553998"/>
+            </a:xfrm>
+            <a:prstGeom prst="rect">
+              <a:avLst/>
+            </a:prstGeom>
+            <a:noFill/>
+            <a:ln w="3175">
+              <a:solidFill>
+                <a:schemeClr val="tx1">
+                  <a:lumMod val="65000"/>
+                  <a:lumOff val="35000"/>
+                </a:schemeClr>
+              </a:solidFill>
+            </a:ln>
+          </p:spPr>
+          <p:style>
+            <a:lnRef idx="2">
+              <a:schemeClr val="accent1">
+                <a:shade val="15000"/>
+              </a:schemeClr>
+            </a:lnRef>
+            <a:fillRef idx="1">
+              <a:schemeClr val="accent1"/>
+            </a:fillRef>
+            <a:effectRef idx="0">
+              <a:schemeClr val="accent1"/>
+            </a:effectRef>
+            <a:fontRef idx="minor">
+              <a:schemeClr val="lt1"/>
+            </a:fontRef>
+          </p:style>
+          <p:txBody>
+            <a:bodyPr rtlCol="0" anchor="ctr"/>
+            <a:lstStyle/>
+            <a:p>
+              <a:pPr algn="ctr"/>
+              <a:endParaRPr lang="it-IT" sz="800"/>
+            </a:p>
+          </p:txBody>
+        </p:sp>
+        <p:cxnSp>
+          <p:nvCxnSpPr>
+            <p:cNvPr id="36" name="Straight Arrow Connector 35">
+              <a:extLst>
+                <a:ext uri="{FF2B5EF4-FFF2-40B4-BE49-F238E27FC236}">
+                  <a16:creationId xmlns:a16="http://schemas.microsoft.com/office/drawing/2014/main" id="{994F828A-EEDA-8FF4-1317-E8AF2D093D97}"/>
+                </a:ext>
+              </a:extLst>
+            </p:cNvPr>
+            <p:cNvCxnSpPr>
+              <a:cxnSpLocks/>
+            </p:cNvCxnSpPr>
+            <p:nvPr/>
+          </p:nvCxnSpPr>
+          <p:spPr>
+            <a:xfrm>
+              <a:off x="2020285" y="877338"/>
+              <a:ext cx="0" cy="270000"/>
+            </a:xfrm>
+            <a:prstGeom prst="straightConnector1">
+              <a:avLst/>
+            </a:prstGeom>
+            <a:ln w="3175">
+              <a:solidFill>
+                <a:schemeClr val="tx1">
+                  <a:lumMod val="65000"/>
+                  <a:lumOff val="35000"/>
+                </a:schemeClr>
+              </a:solidFill>
+              <a:tailEnd type="triangle"/>
+            </a:ln>
+          </p:spPr>
+          <p:style>
+            <a:lnRef idx="2">
+              <a:schemeClr val="accent1"/>
+            </a:lnRef>
+            <a:fillRef idx="0">
+              <a:schemeClr val="accent1"/>
+            </a:fillRef>
+            <a:effectRef idx="1">
+              <a:schemeClr val="accent1"/>
+            </a:effectRef>
+            <a:fontRef idx="minor">
+              <a:schemeClr val="tx1"/>
+            </a:fontRef>
+          </p:style>
+        </p:cxnSp>
+        <p:sp>
+          <p:nvSpPr>
+            <p:cNvPr id="37" name="Diamond 36">
+              <a:extLst>
+                <a:ext uri="{FF2B5EF4-FFF2-40B4-BE49-F238E27FC236}">
+                  <a16:creationId xmlns:a16="http://schemas.microsoft.com/office/drawing/2014/main" id="{A15B6D45-79F5-B9F8-C9E6-C2B4A302D2EA}"/>
+                </a:ext>
+              </a:extLst>
+            </p:cNvPr>
+            <p:cNvSpPr/>
+            <p:nvPr/>
+          </p:nvSpPr>
+          <p:spPr>
+            <a:xfrm>
+              <a:off x="1188009" y="1133340"/>
+              <a:ext cx="1673724" cy="881092"/>
+            </a:xfrm>
+            <a:prstGeom prst="diamond">
+              <a:avLst/>
+            </a:prstGeom>
+            <a:noFill/>
+            <a:ln w="3175">
+              <a:solidFill>
+                <a:schemeClr val="tx1">
+                  <a:lumMod val="65000"/>
+                  <a:lumOff val="35000"/>
+                </a:schemeClr>
+              </a:solidFill>
+            </a:ln>
+          </p:spPr>
+          <p:style>
+            <a:lnRef idx="2">
+              <a:schemeClr val="accent1">
+                <a:shade val="15000"/>
+              </a:schemeClr>
+            </a:lnRef>
+            <a:fillRef idx="1">
+              <a:schemeClr val="accent1"/>
+            </a:fillRef>
+            <a:effectRef idx="0">
+              <a:schemeClr val="accent1"/>
+            </a:effectRef>
+            <a:fontRef idx="minor">
+              <a:schemeClr val="lt1"/>
+            </a:fontRef>
+          </p:style>
+          <p:txBody>
+            <a:bodyPr rtlCol="0" anchor="ctr"/>
+            <a:lstStyle/>
+            <a:p>
+              <a:pPr algn="ctr"/>
+              <a:endParaRPr lang="it-IT" sz="800"/>
+            </a:p>
+          </p:txBody>
+        </p:sp>
+        <p:sp>
+          <p:nvSpPr>
+            <p:cNvPr id="38" name="TextBox 37">
+              <a:extLst>
+                <a:ext uri="{FF2B5EF4-FFF2-40B4-BE49-F238E27FC236}">
+                  <a16:creationId xmlns:a16="http://schemas.microsoft.com/office/drawing/2014/main" id="{C12DC1C5-1801-3D4B-2A03-DAB145A118F6}"/>
                 </a:ext>
               </a:extLst>
             </p:cNvPr>
@@ -3062,8 +3775,8 @@
           </p:nvSpPr>
           <p:spPr>
             <a:xfrm>
-              <a:off x="1811110" y="701588"/>
-              <a:ext cx="1378552" cy="553998"/>
+              <a:off x="1331007" y="1280303"/>
+              <a:ext cx="1378552" cy="584775"/>
             </a:xfrm>
             <a:prstGeom prst="rect">
               <a:avLst/>
@@ -3081,326 +3794,534 @@
             <a:p>
               <a:pPr algn="ctr"/>
               <a:r>
-                <a:rPr lang="en-US" sz="1000" dirty="0">
+                <a:rPr lang="en-US" sz="800" dirty="0">
                   <a:solidFill>
                     <a:srgbClr val="333333"/>
                   </a:solidFill>
                   <a:latin typeface="Calibri Light" panose="020F0302020204030204" pitchFamily="34" charset="0"/>
                   <a:cs typeface="Calibri Light" panose="020F0302020204030204" pitchFamily="34" charset="0"/>
                 </a:rPr>
-                <a:t>ERA5-ecPoint</a:t>
+                <a:t>Is the forecast</a:t>
               </a:r>
             </a:p>
             <a:p>
               <a:pPr algn="ctr"/>
               <a:r>
-                <a:rPr lang="en-US" sz="1000" dirty="0">
+                <a:rPr lang="en-US" sz="800" dirty="0">
                   <a:solidFill>
                     <a:srgbClr val="333333"/>
                   </a:solidFill>
                   <a:latin typeface="Calibri Light" panose="020F0302020204030204" pitchFamily="34" charset="0"/>
                   <a:cs typeface="Calibri Light" panose="020F0302020204030204" pitchFamily="34" charset="0"/>
                 </a:rPr>
-                <a:t>rainfall forecasts</a:t>
+                <a:t>&gt;= threshold</a:t>
               </a:r>
             </a:p>
             <a:p>
               <a:pPr algn="ctr"/>
               <a:r>
-                <a:rPr lang="en-US" sz="1000" dirty="0">
+                <a:rPr lang="en-US" sz="800" dirty="0">
                   <a:solidFill>
                     <a:srgbClr val="333333"/>
                   </a:solidFill>
                   <a:latin typeface="Calibri Light" panose="020F0302020204030204" pitchFamily="34" charset="0"/>
                   <a:cs typeface="Calibri Light" panose="020F0302020204030204" pitchFamily="34" charset="0"/>
                 </a:rPr>
-                <a:t>(mm/24h, point-scale)</a:t>
+                <a:t>(i.e., rainfall return period - in years)</a:t>
               </a:r>
             </a:p>
           </p:txBody>
         </p:sp>
-        <p:pic>
-          <p:nvPicPr>
-            <p:cNvPr id="91" name="Picture 90">
+        <p:grpSp>
+          <p:nvGrpSpPr>
+            <p:cNvPr id="39" name="Group 38">
               <a:extLst>
                 <a:ext uri="{FF2B5EF4-FFF2-40B4-BE49-F238E27FC236}">
-                  <a16:creationId xmlns:a16="http://schemas.microsoft.com/office/drawing/2014/main" id="{9DB3C0CB-F121-AB89-6F90-0A67900A971C}"/>
+                  <a16:creationId xmlns:a16="http://schemas.microsoft.com/office/drawing/2014/main" id="{87DBA8D6-574F-BFA7-7C61-9430A7E58D71}"/>
                 </a:ext>
               </a:extLst>
             </p:cNvPr>
-            <p:cNvPicPr>
-              <a:picLocks noChangeAspect="1"/>
-            </p:cNvPicPr>
+            <p:cNvGrpSpPr/>
             <p:nvPr/>
-          </p:nvPicPr>
-          <p:blipFill>
-            <a:blip r:embed="rId2"/>
-            <a:stretch>
-              <a:fillRect/>
-            </a:stretch>
-          </p:blipFill>
+          </p:nvGrpSpPr>
+          <p:grpSpPr>
+            <a:xfrm>
+              <a:off x="696029" y="1572691"/>
+              <a:ext cx="504428" cy="270000"/>
+              <a:chOff x="990600" y="1829019"/>
+              <a:chExt cx="504428" cy="270000"/>
+            </a:xfrm>
+          </p:grpSpPr>
+          <p:cxnSp>
+            <p:nvCxnSpPr>
+              <p:cNvPr id="40" name="Straight Connector 39">
+                <a:extLst>
+                  <a:ext uri="{FF2B5EF4-FFF2-40B4-BE49-F238E27FC236}">
+                    <a16:creationId xmlns:a16="http://schemas.microsoft.com/office/drawing/2014/main" id="{41AEF2FB-B8B7-FD51-6580-D8EE648BEC3C}"/>
+                  </a:ext>
+                </a:extLst>
+              </p:cNvPr>
+              <p:cNvCxnSpPr/>
+              <p:nvPr/>
+            </p:nvCxnSpPr>
+            <p:spPr>
+              <a:xfrm flipH="1">
+                <a:off x="990600" y="1830214"/>
+                <a:ext cx="504428" cy="0"/>
+              </a:xfrm>
+              <a:prstGeom prst="line">
+                <a:avLst/>
+              </a:prstGeom>
+              <a:ln w="3175">
+                <a:solidFill>
+                  <a:schemeClr val="tx1">
+                    <a:lumMod val="65000"/>
+                    <a:lumOff val="35000"/>
+                  </a:schemeClr>
+                </a:solidFill>
+              </a:ln>
+            </p:spPr>
+            <p:style>
+              <a:lnRef idx="2">
+                <a:schemeClr val="accent1"/>
+              </a:lnRef>
+              <a:fillRef idx="0">
+                <a:schemeClr val="accent1"/>
+              </a:fillRef>
+              <a:effectRef idx="1">
+                <a:schemeClr val="accent1"/>
+              </a:effectRef>
+              <a:fontRef idx="minor">
+                <a:schemeClr val="tx1"/>
+              </a:fontRef>
+            </p:style>
+          </p:cxnSp>
+          <p:cxnSp>
+            <p:nvCxnSpPr>
+              <p:cNvPr id="41" name="Straight Arrow Connector 40">
+                <a:extLst>
+                  <a:ext uri="{FF2B5EF4-FFF2-40B4-BE49-F238E27FC236}">
+                    <a16:creationId xmlns:a16="http://schemas.microsoft.com/office/drawing/2014/main" id="{3299449E-5119-A4D6-3875-32AB3FABB6E3}"/>
+                  </a:ext>
+                </a:extLst>
+              </p:cNvPr>
+              <p:cNvCxnSpPr>
+                <a:cxnSpLocks/>
+              </p:cNvCxnSpPr>
+              <p:nvPr/>
+            </p:nvCxnSpPr>
+            <p:spPr>
+              <a:xfrm>
+                <a:off x="990600" y="1829019"/>
+                <a:ext cx="0" cy="270000"/>
+              </a:xfrm>
+              <a:prstGeom prst="straightConnector1">
+                <a:avLst/>
+              </a:prstGeom>
+              <a:ln w="3175">
+                <a:solidFill>
+                  <a:schemeClr val="tx1">
+                    <a:lumMod val="65000"/>
+                    <a:lumOff val="35000"/>
+                  </a:schemeClr>
+                </a:solidFill>
+                <a:tailEnd type="triangle"/>
+              </a:ln>
+            </p:spPr>
+            <p:style>
+              <a:lnRef idx="2">
+                <a:schemeClr val="accent1"/>
+              </a:lnRef>
+              <a:fillRef idx="0">
+                <a:schemeClr val="accent1"/>
+              </a:fillRef>
+              <a:effectRef idx="1">
+                <a:schemeClr val="accent1"/>
+              </a:effectRef>
+              <a:fontRef idx="minor">
+                <a:schemeClr val="tx1"/>
+              </a:fontRef>
+            </p:style>
+          </p:cxnSp>
+        </p:grpSp>
+        <p:grpSp>
+          <p:nvGrpSpPr>
+            <p:cNvPr id="42" name="Group 41">
+              <a:extLst>
+                <a:ext uri="{FF2B5EF4-FFF2-40B4-BE49-F238E27FC236}">
+                  <a16:creationId xmlns:a16="http://schemas.microsoft.com/office/drawing/2014/main" id="{00DC0CBC-1589-645C-A091-E3BCB3E252AB}"/>
+                </a:ext>
+              </a:extLst>
+            </p:cNvPr>
+            <p:cNvGrpSpPr/>
+            <p:nvPr/>
+          </p:nvGrpSpPr>
+          <p:grpSpPr>
+            <a:xfrm flipH="1">
+              <a:off x="2856939" y="1572691"/>
+              <a:ext cx="504428" cy="270000"/>
+              <a:chOff x="990600" y="1829019"/>
+              <a:chExt cx="504428" cy="270000"/>
+            </a:xfrm>
+          </p:grpSpPr>
+          <p:cxnSp>
+            <p:nvCxnSpPr>
+              <p:cNvPr id="43" name="Straight Connector 42">
+                <a:extLst>
+                  <a:ext uri="{FF2B5EF4-FFF2-40B4-BE49-F238E27FC236}">
+                    <a16:creationId xmlns:a16="http://schemas.microsoft.com/office/drawing/2014/main" id="{39580AA1-A4FB-6BA6-E7AE-1F2DF9BCC18F}"/>
+                  </a:ext>
+                </a:extLst>
+              </p:cNvPr>
+              <p:cNvCxnSpPr/>
+              <p:nvPr/>
+            </p:nvCxnSpPr>
+            <p:spPr>
+              <a:xfrm flipH="1">
+                <a:off x="990600" y="1830214"/>
+                <a:ext cx="504428" cy="0"/>
+              </a:xfrm>
+              <a:prstGeom prst="line">
+                <a:avLst/>
+              </a:prstGeom>
+              <a:ln w="3175">
+                <a:solidFill>
+                  <a:schemeClr val="tx1">
+                    <a:lumMod val="65000"/>
+                    <a:lumOff val="35000"/>
+                  </a:schemeClr>
+                </a:solidFill>
+              </a:ln>
+            </p:spPr>
+            <p:style>
+              <a:lnRef idx="2">
+                <a:schemeClr val="accent1"/>
+              </a:lnRef>
+              <a:fillRef idx="0">
+                <a:schemeClr val="accent1"/>
+              </a:fillRef>
+              <a:effectRef idx="1">
+                <a:schemeClr val="accent1"/>
+              </a:effectRef>
+              <a:fontRef idx="minor">
+                <a:schemeClr val="tx1"/>
+              </a:fontRef>
+            </p:style>
+          </p:cxnSp>
+          <p:cxnSp>
+            <p:nvCxnSpPr>
+              <p:cNvPr id="44" name="Straight Arrow Connector 43">
+                <a:extLst>
+                  <a:ext uri="{FF2B5EF4-FFF2-40B4-BE49-F238E27FC236}">
+                    <a16:creationId xmlns:a16="http://schemas.microsoft.com/office/drawing/2014/main" id="{EFA8F58F-F6C2-9656-2B09-A5ED3D712B43}"/>
+                  </a:ext>
+                </a:extLst>
+              </p:cNvPr>
+              <p:cNvCxnSpPr>
+                <a:cxnSpLocks/>
+              </p:cNvCxnSpPr>
+              <p:nvPr/>
+            </p:nvCxnSpPr>
+            <p:spPr>
+              <a:xfrm>
+                <a:off x="990600" y="1829019"/>
+                <a:ext cx="0" cy="270000"/>
+              </a:xfrm>
+              <a:prstGeom prst="straightConnector1">
+                <a:avLst/>
+              </a:prstGeom>
+              <a:ln w="3175">
+                <a:solidFill>
+                  <a:schemeClr val="tx1">
+                    <a:lumMod val="65000"/>
+                    <a:lumOff val="35000"/>
+                  </a:schemeClr>
+                </a:solidFill>
+                <a:tailEnd type="triangle"/>
+              </a:ln>
+            </p:spPr>
+            <p:style>
+              <a:lnRef idx="2">
+                <a:schemeClr val="accent1"/>
+              </a:lnRef>
+              <a:fillRef idx="0">
+                <a:schemeClr val="accent1"/>
+              </a:fillRef>
+              <a:effectRef idx="1">
+                <a:schemeClr val="accent1"/>
+              </a:effectRef>
+              <a:fontRef idx="minor">
+                <a:schemeClr val="tx1"/>
+              </a:fontRef>
+            </p:style>
+          </p:cxnSp>
+        </p:grpSp>
+        <p:sp>
+          <p:nvSpPr>
+            <p:cNvPr id="45" name="TextBox 44">
+              <a:extLst>
+                <a:ext uri="{FF2B5EF4-FFF2-40B4-BE49-F238E27FC236}">
+                  <a16:creationId xmlns:a16="http://schemas.microsoft.com/office/drawing/2014/main" id="{AEF2F405-62A6-9184-E2DA-F8586E4DAAA1}"/>
+                </a:ext>
+              </a:extLst>
+            </p:cNvPr>
+            <p:cNvSpPr txBox="1"/>
+            <p:nvPr/>
+          </p:nvSpPr>
           <p:spPr>
             <a:xfrm>
-              <a:off x="1262387" y="701588"/>
-              <a:ext cx="630000" cy="540000"/>
+              <a:off x="102029" y="1842691"/>
+              <a:ext cx="1188000" cy="461665"/>
             </a:xfrm>
             <a:prstGeom prst="rect">
               <a:avLst/>
             </a:prstGeom>
+            <a:solidFill>
+              <a:srgbClr val="DBC1AF"/>
+            </a:solidFill>
+            <a:ln w="3175">
+              <a:solidFill>
+                <a:schemeClr val="tx1">
+                  <a:lumMod val="65000"/>
+                  <a:lumOff val="35000"/>
+                </a:schemeClr>
+              </a:solidFill>
+            </a:ln>
           </p:spPr>
-        </p:pic>
-      </p:grpSp>
-      <p:sp>
-        <p:nvSpPr>
-          <p:cNvPr id="92" name="Rectangle 91">
-            <a:extLst>
-              <a:ext uri="{FF2B5EF4-FFF2-40B4-BE49-F238E27FC236}">
-                <a16:creationId xmlns:a16="http://schemas.microsoft.com/office/drawing/2014/main" id="{5EA3B3E5-BDE1-8300-691A-8B995A0278E4}"/>
-              </a:ext>
-            </a:extLst>
-          </p:cNvPr>
-          <p:cNvSpPr/>
-          <p:nvPr/>
-        </p:nvSpPr>
-        <p:spPr>
-          <a:xfrm>
-            <a:off x="990600" y="419648"/>
-            <a:ext cx="1997417" cy="553998"/>
-          </a:xfrm>
-          <a:prstGeom prst="rect">
-            <a:avLst/>
-          </a:prstGeom>
-          <a:noFill/>
-          <a:ln w="3175">
-            <a:solidFill>
-              <a:schemeClr val="tx1">
-                <a:lumMod val="65000"/>
-                <a:lumOff val="35000"/>
-              </a:schemeClr>
-            </a:solidFill>
-          </a:ln>
-        </p:spPr>
-        <p:style>
-          <a:lnRef idx="2">
-            <a:schemeClr val="accent1">
-              <a:shade val="15000"/>
-            </a:schemeClr>
-          </a:lnRef>
-          <a:fillRef idx="1">
-            <a:schemeClr val="accent1"/>
-          </a:fillRef>
-          <a:effectRef idx="0">
-            <a:schemeClr val="accent1"/>
-          </a:effectRef>
-          <a:fontRef idx="minor">
-            <a:schemeClr val="lt1"/>
-          </a:fontRef>
-        </p:style>
-        <p:txBody>
-          <a:bodyPr rtlCol="0" anchor="ctr"/>
-          <a:lstStyle/>
-          <a:p>
-            <a:pPr algn="ctr"/>
-            <a:endParaRPr lang="it-IT"/>
-          </a:p>
-        </p:txBody>
-      </p:sp>
-      <p:cxnSp>
-        <p:nvCxnSpPr>
-          <p:cNvPr id="93" name="Straight Arrow Connector 92">
-            <a:extLst>
-              <a:ext uri="{FF2B5EF4-FFF2-40B4-BE49-F238E27FC236}">
-                <a16:creationId xmlns:a16="http://schemas.microsoft.com/office/drawing/2014/main" id="{994F828A-EEDA-8FF4-1317-E8AF2D093D97}"/>
-              </a:ext>
-            </a:extLst>
-          </p:cNvPr>
-          <p:cNvCxnSpPr>
-            <a:cxnSpLocks/>
-          </p:cNvCxnSpPr>
-          <p:nvPr/>
-        </p:nvCxnSpPr>
-        <p:spPr>
-          <a:xfrm>
-            <a:off x="2030945" y="973646"/>
-            <a:ext cx="0" cy="270000"/>
-          </a:xfrm>
-          <a:prstGeom prst="straightConnector1">
-            <a:avLst/>
-          </a:prstGeom>
-          <a:ln w="3175">
-            <a:solidFill>
-              <a:schemeClr val="tx1">
-                <a:lumMod val="65000"/>
-                <a:lumOff val="35000"/>
-              </a:schemeClr>
-            </a:solidFill>
-            <a:tailEnd type="triangle"/>
-          </a:ln>
-        </p:spPr>
-        <p:style>
-          <a:lnRef idx="2">
-            <a:schemeClr val="accent1"/>
-          </a:lnRef>
-          <a:fillRef idx="0">
-            <a:schemeClr val="accent1"/>
-          </a:fillRef>
-          <a:effectRef idx="1">
-            <a:schemeClr val="accent1"/>
-          </a:effectRef>
-          <a:fontRef idx="minor">
-            <a:schemeClr val="tx1"/>
-          </a:fontRef>
-        </p:style>
-      </p:cxnSp>
-      <p:sp>
-        <p:nvSpPr>
-          <p:cNvPr id="94" name="Diamond 93">
-            <a:extLst>
-              <a:ext uri="{FF2B5EF4-FFF2-40B4-BE49-F238E27FC236}">
-                <a16:creationId xmlns:a16="http://schemas.microsoft.com/office/drawing/2014/main" id="{A15B6D45-79F5-B9F8-C9E6-C2B4A302D2EA}"/>
-              </a:ext>
-            </a:extLst>
-          </p:cNvPr>
-          <p:cNvSpPr/>
-          <p:nvPr/>
-        </p:nvSpPr>
-        <p:spPr>
-          <a:xfrm>
-            <a:off x="1495028" y="1229648"/>
-            <a:ext cx="1080000" cy="881092"/>
-          </a:xfrm>
-          <a:prstGeom prst="diamond">
-            <a:avLst/>
-          </a:prstGeom>
-          <a:noFill/>
-          <a:ln w="3175">
-            <a:solidFill>
-              <a:schemeClr val="tx1">
-                <a:lumMod val="65000"/>
-                <a:lumOff val="35000"/>
-              </a:schemeClr>
-            </a:solidFill>
-          </a:ln>
-        </p:spPr>
-        <p:style>
-          <a:lnRef idx="2">
-            <a:schemeClr val="accent1">
-              <a:shade val="15000"/>
-            </a:schemeClr>
-          </a:lnRef>
-          <a:fillRef idx="1">
-            <a:schemeClr val="accent1"/>
-          </a:fillRef>
-          <a:effectRef idx="0">
-            <a:schemeClr val="accent1"/>
-          </a:effectRef>
-          <a:fontRef idx="minor">
-            <a:schemeClr val="lt1"/>
-          </a:fontRef>
-        </p:style>
-        <p:txBody>
-          <a:bodyPr rtlCol="0" anchor="ctr"/>
-          <a:lstStyle/>
-          <a:p>
-            <a:pPr algn="ctr"/>
-            <a:endParaRPr lang="it-IT"/>
-          </a:p>
-        </p:txBody>
-      </p:sp>
-      <p:sp>
-        <p:nvSpPr>
-          <p:cNvPr id="95" name="TextBox 94">
-            <a:extLst>
-              <a:ext uri="{FF2B5EF4-FFF2-40B4-BE49-F238E27FC236}">
-                <a16:creationId xmlns:a16="http://schemas.microsoft.com/office/drawing/2014/main" id="{C12DC1C5-1801-3D4B-2A03-DAB145A118F6}"/>
-              </a:ext>
-            </a:extLst>
-          </p:cNvPr>
-          <p:cNvSpPr txBox="1"/>
-          <p:nvPr/>
-        </p:nvSpPr>
-        <p:spPr>
-          <a:xfrm>
-            <a:off x="1345752" y="1476564"/>
-            <a:ext cx="1378552" cy="400110"/>
-          </a:xfrm>
-          <a:prstGeom prst="rect">
-            <a:avLst/>
-          </a:prstGeom>
-          <a:noFill/>
-          <a:ln w="3175">
-            <a:noFill/>
-          </a:ln>
-        </p:spPr>
-        <p:txBody>
-          <a:bodyPr wrap="square" rtlCol="0">
-            <a:spAutoFit/>
-          </a:bodyPr>
-          <a:lstStyle/>
-          <a:p>
-            <a:pPr algn="ctr"/>
-            <a:r>
-              <a:rPr lang="en-US" sz="1000" dirty="0">
-                <a:solidFill>
-                  <a:srgbClr val="333333"/>
-                </a:solidFill>
-                <a:latin typeface="Calibri Light" panose="020F0302020204030204" pitchFamily="34" charset="0"/>
-                <a:cs typeface="Calibri Light" panose="020F0302020204030204" pitchFamily="34" charset="0"/>
-              </a:rPr>
-              <a:t>Is the forecast</a:t>
-            </a:r>
-          </a:p>
-          <a:p>
-            <a:pPr algn="ctr"/>
-            <a:r>
-              <a:rPr lang="en-US" sz="1000" dirty="0">
-                <a:solidFill>
-                  <a:srgbClr val="333333"/>
-                </a:solidFill>
-                <a:latin typeface="Calibri Light" panose="020F0302020204030204" pitchFamily="34" charset="0"/>
-                <a:cs typeface="Calibri Light" panose="020F0302020204030204" pitchFamily="34" charset="0"/>
-              </a:rPr>
-              <a:t>&gt;= threshold</a:t>
-            </a:r>
-          </a:p>
-        </p:txBody>
-      </p:sp>
-      <p:grpSp>
-        <p:nvGrpSpPr>
-          <p:cNvPr id="96" name="Group 95">
-            <a:extLst>
-              <a:ext uri="{FF2B5EF4-FFF2-40B4-BE49-F238E27FC236}">
-                <a16:creationId xmlns:a16="http://schemas.microsoft.com/office/drawing/2014/main" id="{87DBA8D6-574F-BFA7-7C61-9430A7E58D71}"/>
-              </a:ext>
-            </a:extLst>
-          </p:cNvPr>
-          <p:cNvGrpSpPr/>
-          <p:nvPr/>
-        </p:nvGrpSpPr>
-        <p:grpSpPr>
-          <a:xfrm>
-            <a:off x="990600" y="1668999"/>
-            <a:ext cx="504428" cy="270000"/>
-            <a:chOff x="990600" y="1829019"/>
-            <a:chExt cx="504428" cy="270000"/>
-          </a:xfrm>
-        </p:grpSpPr>
-        <p:cxnSp>
-          <p:nvCxnSpPr>
-            <p:cNvPr id="97" name="Straight Connector 96">
+          <p:txBody>
+            <a:bodyPr wrap="square" rtlCol="0">
+              <a:spAutoFit/>
+            </a:bodyPr>
+            <a:lstStyle/>
+            <a:p>
+              <a:pPr algn="ctr"/>
+              <a:r>
+                <a:rPr lang="en-US" sz="800" dirty="0">
+                  <a:solidFill>
+                    <a:srgbClr val="333333"/>
+                  </a:solidFill>
+                  <a:latin typeface="Calibri Light" panose="020F0302020204030204" pitchFamily="34" charset="0"/>
+                  <a:cs typeface="Calibri Light" panose="020F0302020204030204" pitchFamily="34" charset="0"/>
+                </a:rPr>
+                <a:t>Non-event</a:t>
+              </a:r>
+            </a:p>
+            <a:p>
+              <a:pPr algn="ctr"/>
+              <a:r>
+                <a:rPr lang="en-US" sz="800" dirty="0">
+                  <a:solidFill>
+                    <a:srgbClr val="333333"/>
+                  </a:solidFill>
+                  <a:latin typeface="Calibri Light" panose="020F0302020204030204" pitchFamily="34" charset="0"/>
+                  <a:cs typeface="Calibri Light" panose="020F0302020204030204" pitchFamily="34" charset="0"/>
+                </a:rPr>
+                <a:t>(no flash flood risk)</a:t>
+              </a:r>
+            </a:p>
+            <a:p>
+              <a:pPr algn="ctr"/>
+              <a:r>
+                <a:rPr lang="en-US" sz="800" b="1" dirty="0">
+                  <a:solidFill>
+                    <a:srgbClr val="333333"/>
+                  </a:solidFill>
+                  <a:latin typeface="Calibri" panose="020F0502020204030204" pitchFamily="34" charset="0"/>
+                  <a:ea typeface="Calibri" panose="020F0502020204030204" pitchFamily="34" charset="0"/>
+                  <a:cs typeface="Calibri" panose="020F0502020204030204" pitchFamily="34" charset="0"/>
+                </a:rPr>
+                <a:t>0</a:t>
+              </a:r>
+            </a:p>
+          </p:txBody>
+        </p:sp>
+        <p:sp>
+          <p:nvSpPr>
+            <p:cNvPr id="46" name="TextBox 45">
               <a:extLst>
                 <a:ext uri="{FF2B5EF4-FFF2-40B4-BE49-F238E27FC236}">
-                  <a16:creationId xmlns:a16="http://schemas.microsoft.com/office/drawing/2014/main" id="{41AEF2FB-B8B7-FD51-6580-D8EE648BEC3C}"/>
+                  <a16:creationId xmlns:a16="http://schemas.microsoft.com/office/drawing/2014/main" id="{3AC1E00C-7CC8-E558-16F9-CBB16592A278}"/>
                 </a:ext>
               </a:extLst>
             </p:cNvPr>
-            <p:cNvCxnSpPr/>
+            <p:cNvSpPr txBox="1"/>
+            <p:nvPr/>
+          </p:nvSpPr>
+          <p:spPr>
+            <a:xfrm>
+              <a:off x="745177" y="1366906"/>
+              <a:ext cx="409203" cy="215444"/>
+            </a:xfrm>
+            <a:prstGeom prst="rect">
+              <a:avLst/>
+            </a:prstGeom>
+            <a:noFill/>
+            <a:ln w="3175">
+              <a:noFill/>
+            </a:ln>
+          </p:spPr>
+          <p:txBody>
+            <a:bodyPr wrap="square" rtlCol="0">
+              <a:spAutoFit/>
+            </a:bodyPr>
+            <a:lstStyle/>
+            <a:p>
+              <a:pPr algn="ctr"/>
+              <a:r>
+                <a:rPr lang="en-US" sz="800" dirty="0">
+                  <a:solidFill>
+                    <a:srgbClr val="333333"/>
+                  </a:solidFill>
+                  <a:latin typeface="Calibri Light" panose="020F0302020204030204" pitchFamily="34" charset="0"/>
+                  <a:cs typeface="Calibri Light" panose="020F0302020204030204" pitchFamily="34" charset="0"/>
+                </a:rPr>
+                <a:t>NO</a:t>
+              </a:r>
+            </a:p>
+          </p:txBody>
+        </p:sp>
+        <p:sp>
+          <p:nvSpPr>
+            <p:cNvPr id="47" name="TextBox 46">
+              <a:extLst>
+                <a:ext uri="{FF2B5EF4-FFF2-40B4-BE49-F238E27FC236}">
+                  <a16:creationId xmlns:a16="http://schemas.microsoft.com/office/drawing/2014/main" id="{E2C60F2E-5AEC-FD98-E016-93A8494C37D8}"/>
+                </a:ext>
+              </a:extLst>
+            </p:cNvPr>
+            <p:cNvSpPr txBox="1"/>
+            <p:nvPr/>
+          </p:nvSpPr>
+          <p:spPr>
+            <a:xfrm>
+              <a:off x="2904551" y="1366906"/>
+              <a:ext cx="409203" cy="215444"/>
+            </a:xfrm>
+            <a:prstGeom prst="rect">
+              <a:avLst/>
+            </a:prstGeom>
+            <a:noFill/>
+            <a:ln w="3175">
+              <a:noFill/>
+            </a:ln>
+          </p:spPr>
+          <p:txBody>
+            <a:bodyPr wrap="square" rtlCol="0">
+              <a:spAutoFit/>
+            </a:bodyPr>
+            <a:lstStyle/>
+            <a:p>
+              <a:pPr algn="ctr"/>
+              <a:r>
+                <a:rPr lang="en-US" sz="800" dirty="0">
+                  <a:solidFill>
+                    <a:srgbClr val="333333"/>
+                  </a:solidFill>
+                  <a:latin typeface="Calibri Light" panose="020F0302020204030204" pitchFamily="34" charset="0"/>
+                  <a:cs typeface="Calibri Light" panose="020F0302020204030204" pitchFamily="34" charset="0"/>
+                </a:rPr>
+                <a:t>YES</a:t>
+              </a:r>
+            </a:p>
+          </p:txBody>
+        </p:sp>
+        <p:sp>
+          <p:nvSpPr>
+            <p:cNvPr id="48" name="TextBox 47">
+              <a:extLst>
+                <a:ext uri="{FF2B5EF4-FFF2-40B4-BE49-F238E27FC236}">
+                  <a16:creationId xmlns:a16="http://schemas.microsoft.com/office/drawing/2014/main" id="{094E29AE-C474-3CCD-52C0-D085CCBD05CB}"/>
+                </a:ext>
+              </a:extLst>
+            </p:cNvPr>
+            <p:cNvSpPr txBox="1"/>
+            <p:nvPr/>
+          </p:nvSpPr>
+          <p:spPr>
+            <a:xfrm>
+              <a:off x="2767367" y="1843750"/>
+              <a:ext cx="1188000" cy="461665"/>
+            </a:xfrm>
+            <a:prstGeom prst="rect">
+              <a:avLst/>
+            </a:prstGeom>
+            <a:solidFill>
+              <a:srgbClr val="C1E5EC"/>
+            </a:solidFill>
+            <a:ln w="3175">
+              <a:solidFill>
+                <a:schemeClr val="tx1">
+                  <a:lumMod val="65000"/>
+                  <a:lumOff val="35000"/>
+                </a:schemeClr>
+              </a:solidFill>
+            </a:ln>
+          </p:spPr>
+          <p:txBody>
+            <a:bodyPr wrap="square" rtlCol="0">
+              <a:spAutoFit/>
+            </a:bodyPr>
+            <a:lstStyle/>
+            <a:p>
+              <a:pPr algn="ctr"/>
+              <a:r>
+                <a:rPr lang="en-US" sz="800" dirty="0">
+                  <a:solidFill>
+                    <a:srgbClr val="333333"/>
+                  </a:solidFill>
+                  <a:latin typeface="Calibri Light" panose="020F0302020204030204" pitchFamily="34" charset="0"/>
+                  <a:cs typeface="Calibri Light" panose="020F0302020204030204" pitchFamily="34" charset="0"/>
+                </a:rPr>
+                <a:t>Yes-event</a:t>
+              </a:r>
+            </a:p>
+            <a:p>
+              <a:pPr algn="ctr"/>
+              <a:r>
+                <a:rPr lang="en-US" sz="800" dirty="0">
+                  <a:solidFill>
+                    <a:srgbClr val="333333"/>
+                  </a:solidFill>
+                  <a:latin typeface="Calibri Light" panose="020F0302020204030204" pitchFamily="34" charset="0"/>
+                  <a:cs typeface="Calibri Light" panose="020F0302020204030204" pitchFamily="34" charset="0"/>
+                </a:rPr>
+                <a:t>(flash flood risk)</a:t>
+              </a:r>
+            </a:p>
+            <a:p>
+              <a:pPr algn="ctr"/>
+              <a:r>
+                <a:rPr lang="en-US" sz="800" b="1" dirty="0">
+                  <a:solidFill>
+                    <a:srgbClr val="32999E"/>
+                  </a:solidFill>
+                  <a:latin typeface="Calibri" panose="020F0502020204030204" pitchFamily="34" charset="0"/>
+                  <a:ea typeface="Calibri" panose="020F0502020204030204" pitchFamily="34" charset="0"/>
+                  <a:cs typeface="Calibri" panose="020F0502020204030204" pitchFamily="34" charset="0"/>
+                </a:rPr>
+                <a:t>1</a:t>
+              </a:r>
+            </a:p>
+          </p:txBody>
+        </p:sp>
+        <p:cxnSp>
+          <p:nvCxnSpPr>
+            <p:cNvPr id="49" name="Straight Connector 48">
+              <a:extLst>
+                <a:ext uri="{FF2B5EF4-FFF2-40B4-BE49-F238E27FC236}">
+                  <a16:creationId xmlns:a16="http://schemas.microsoft.com/office/drawing/2014/main" id="{7D935352-A1CB-CD98-5B07-68B96108C511}"/>
+                </a:ext>
+              </a:extLst>
+            </p:cNvPr>
+            <p:cNvCxnSpPr>
+              <a:cxnSpLocks/>
+            </p:cNvCxnSpPr>
             <p:nvPr/>
           </p:nvCxnSpPr>
           <p:spPr>
-            <a:xfrm flipH="1">
-              <a:off x="990600" y="1830214"/>
-              <a:ext cx="504428" cy="0"/>
+            <a:xfrm rot="16200000">
+              <a:off x="3226367" y="2441499"/>
+              <a:ext cx="270000" cy="0"/>
             </a:xfrm>
             <a:prstGeom prst="line">
               <a:avLst/>
@@ -3431,10 +4352,10 @@
         </p:cxnSp>
         <p:cxnSp>
           <p:nvCxnSpPr>
-            <p:cNvPr id="98" name="Straight Arrow Connector 97">
+            <p:cNvPr id="50" name="Straight Arrow Connector 49">
               <a:extLst>
                 <a:ext uri="{FF2B5EF4-FFF2-40B4-BE49-F238E27FC236}">
-                  <a16:creationId xmlns:a16="http://schemas.microsoft.com/office/drawing/2014/main" id="{3299449E-5119-A4D6-3875-32AB3FABB6E3}"/>
+                  <a16:creationId xmlns:a16="http://schemas.microsoft.com/office/drawing/2014/main" id="{88DFB1B9-2D33-4164-D9A3-A66D31087C2A}"/>
                 </a:ext>
               </a:extLst>
             </p:cNvPr>
@@ -3444,8 +4365,8 @@
             <p:nvPr/>
           </p:nvCxnSpPr>
           <p:spPr>
-            <a:xfrm>
-              <a:off x="990600" y="1829019"/>
+            <a:xfrm flipH="1">
+              <a:off x="2020285" y="2569061"/>
               <a:ext cx="0" cy="270000"/>
             </a:xfrm>
             <a:prstGeom prst="straightConnector1">
@@ -3476,43 +4397,24 @@
             </a:fontRef>
           </p:style>
         </p:cxnSp>
-      </p:grpSp>
-      <p:grpSp>
-        <p:nvGrpSpPr>
-          <p:cNvPr id="99" name="Group 98">
-            <a:extLst>
-              <a:ext uri="{FF2B5EF4-FFF2-40B4-BE49-F238E27FC236}">
-                <a16:creationId xmlns:a16="http://schemas.microsoft.com/office/drawing/2014/main" id="{00DC0CBC-1589-645C-A091-E3BCB3E252AB}"/>
-              </a:ext>
-            </a:extLst>
-          </p:cNvPr>
-          <p:cNvGrpSpPr/>
-          <p:nvPr/>
-        </p:nvGrpSpPr>
-        <p:grpSpPr>
-          <a:xfrm flipH="1">
-            <a:off x="2561296" y="1676619"/>
-            <a:ext cx="504428" cy="270000"/>
-            <a:chOff x="990600" y="1829019"/>
-            <a:chExt cx="504428" cy="270000"/>
-          </a:xfrm>
-        </p:grpSpPr>
         <p:cxnSp>
           <p:nvCxnSpPr>
-            <p:cNvPr id="100" name="Straight Connector 99">
+            <p:cNvPr id="51" name="Straight Connector 50">
               <a:extLst>
                 <a:ext uri="{FF2B5EF4-FFF2-40B4-BE49-F238E27FC236}">
-                  <a16:creationId xmlns:a16="http://schemas.microsoft.com/office/drawing/2014/main" id="{39580AA1-A4FB-6BA6-E7AE-1F2DF9BCC18F}"/>
+                  <a16:creationId xmlns:a16="http://schemas.microsoft.com/office/drawing/2014/main" id="{858CED55-193B-AED5-D807-6ACCF9F7F9B2}"/>
                 </a:ext>
               </a:extLst>
             </p:cNvPr>
-            <p:cNvCxnSpPr/>
+            <p:cNvCxnSpPr>
+              <a:cxnSpLocks/>
+            </p:cNvCxnSpPr>
             <p:nvPr/>
           </p:nvCxnSpPr>
           <p:spPr>
-            <a:xfrm flipH="1">
-              <a:off x="990600" y="1830214"/>
-              <a:ext cx="504428" cy="0"/>
+            <a:xfrm rot="16200000">
+              <a:off x="561029" y="2439356"/>
+              <a:ext cx="270000" cy="0"/>
             </a:xfrm>
             <a:prstGeom prst="line">
               <a:avLst/>
@@ -3543,10 +4445,10 @@
         </p:cxnSp>
         <p:cxnSp>
           <p:nvCxnSpPr>
-            <p:cNvPr id="101" name="Straight Arrow Connector 100">
+            <p:cNvPr id="52" name="Straight Connector 51">
               <a:extLst>
                 <a:ext uri="{FF2B5EF4-FFF2-40B4-BE49-F238E27FC236}">
-                  <a16:creationId xmlns:a16="http://schemas.microsoft.com/office/drawing/2014/main" id="{EFA8F58F-F6C2-9656-2B09-A5ED3D712B43}"/>
+                  <a16:creationId xmlns:a16="http://schemas.microsoft.com/office/drawing/2014/main" id="{81AA77C9-2BA6-9449-258D-DEDF65B8D8A9}"/>
                 </a:ext>
               </a:extLst>
             </p:cNvPr>
@@ -3557,10 +4459,10 @@
           </p:nvCxnSpPr>
           <p:spPr>
             <a:xfrm>
-              <a:off x="990600" y="1829019"/>
-              <a:ext cx="0" cy="270000"/>
+              <a:off x="696029" y="2574219"/>
+              <a:ext cx="2665338" cy="0"/>
             </a:xfrm>
-            <a:prstGeom prst="straightConnector1">
+            <a:prstGeom prst="line">
               <a:avLst/>
             </a:prstGeom>
             <a:ln w="3175">
@@ -3570,7 +4472,6 @@
                   <a:lumOff val="35000"/>
                 </a:schemeClr>
               </a:solidFill>
-              <a:tailEnd type="triangle"/>
             </a:ln>
           </p:spPr>
           <p:style>
@@ -3588,570 +4489,158 @@
             </a:fontRef>
           </p:style>
         </p:cxnSp>
+        <p:grpSp>
+          <p:nvGrpSpPr>
+            <p:cNvPr id="53" name="Group 52">
+              <a:extLst>
+                <a:ext uri="{FF2B5EF4-FFF2-40B4-BE49-F238E27FC236}">
+                  <a16:creationId xmlns:a16="http://schemas.microsoft.com/office/drawing/2014/main" id="{75FFF979-52C9-D42D-37D8-AF2C6E84A00C}"/>
+                </a:ext>
+              </a:extLst>
+            </p:cNvPr>
+            <p:cNvGrpSpPr/>
+            <p:nvPr/>
+          </p:nvGrpSpPr>
+          <p:grpSpPr>
+            <a:xfrm>
+              <a:off x="696028" y="2847901"/>
+              <a:ext cx="2665335" cy="1424422"/>
+              <a:chOff x="761750" y="2947408"/>
+              <a:chExt cx="2499577" cy="1424422"/>
+            </a:xfrm>
+          </p:grpSpPr>
+          <p:pic>
+            <p:nvPicPr>
+              <p:cNvPr id="54" name="Picture 53">
+                <a:extLst>
+                  <a:ext uri="{FF2B5EF4-FFF2-40B4-BE49-F238E27FC236}">
+                    <a16:creationId xmlns:a16="http://schemas.microsoft.com/office/drawing/2014/main" id="{BE52EE0A-1373-B866-C4C7-77A5B2CBCBC8}"/>
+                  </a:ext>
+                </a:extLst>
+              </p:cNvPr>
+              <p:cNvPicPr>
+                <a:picLocks noChangeAspect="1"/>
+              </p:cNvPicPr>
+              <p:nvPr/>
+            </p:nvPicPr>
+            <p:blipFill>
+              <a:blip r:embed="rId3"/>
+              <a:stretch>
+                <a:fillRect/>
+              </a:stretch>
+            </p:blipFill>
+            <p:spPr>
+              <a:xfrm>
+                <a:off x="817449" y="3361613"/>
+                <a:ext cx="2388178" cy="953815"/>
+              </a:xfrm>
+              <a:prstGeom prst="rect">
+                <a:avLst/>
+              </a:prstGeom>
+            </p:spPr>
+          </p:pic>
+          <p:sp>
+            <p:nvSpPr>
+              <p:cNvPr id="55" name="TextBox 54">
+                <a:extLst>
+                  <a:ext uri="{FF2B5EF4-FFF2-40B4-BE49-F238E27FC236}">
+                    <a16:creationId xmlns:a16="http://schemas.microsoft.com/office/drawing/2014/main" id="{3041A462-13E8-E68B-ED83-34E69527A7C3}"/>
+                  </a:ext>
+                </a:extLst>
+              </p:cNvPr>
+              <p:cNvSpPr txBox="1"/>
+              <p:nvPr/>
+            </p:nvSpPr>
+            <p:spPr>
+              <a:xfrm>
+                <a:off x="1099301" y="2985356"/>
+                <a:ext cx="1808696" cy="338554"/>
+              </a:xfrm>
+              <a:prstGeom prst="rect">
+                <a:avLst/>
+              </a:prstGeom>
+              <a:noFill/>
+              <a:ln w="3175">
+                <a:noFill/>
+              </a:ln>
+            </p:spPr>
+            <p:txBody>
+              <a:bodyPr wrap="square" rtlCol="0">
+                <a:spAutoFit/>
+              </a:bodyPr>
+              <a:lstStyle/>
+              <a:p>
+                <a:pPr algn="ctr"/>
+                <a:r>
+                  <a:rPr lang="en-US" sz="800" dirty="0">
+                    <a:solidFill>
+                      <a:srgbClr val="333333"/>
+                    </a:solidFill>
+                    <a:latin typeface="Calibri Light" panose="020F0302020204030204" pitchFamily="34" charset="0"/>
+                    <a:cs typeface="Calibri Light" panose="020F0302020204030204" pitchFamily="34" charset="0"/>
+                  </a:rPr>
+                  <a:t>Rainfall-based predictions of areas at risk of flash floods (binary field)</a:t>
+                </a:r>
+              </a:p>
+            </p:txBody>
+          </p:sp>
+          <p:sp>
+            <p:nvSpPr>
+              <p:cNvPr id="56" name="Rectangle 55">
+                <a:extLst>
+                  <a:ext uri="{FF2B5EF4-FFF2-40B4-BE49-F238E27FC236}">
+                    <a16:creationId xmlns:a16="http://schemas.microsoft.com/office/drawing/2014/main" id="{0ABB75E4-DC24-C31B-F4F0-D6035B2DC0CC}"/>
+                  </a:ext>
+                </a:extLst>
+              </p:cNvPr>
+              <p:cNvSpPr/>
+              <p:nvPr/>
+            </p:nvSpPr>
+            <p:spPr>
+              <a:xfrm>
+                <a:off x="761750" y="2947408"/>
+                <a:ext cx="2499577" cy="1424422"/>
+              </a:xfrm>
+              <a:prstGeom prst="rect">
+                <a:avLst/>
+              </a:prstGeom>
+              <a:noFill/>
+              <a:ln w="3175">
+                <a:solidFill>
+                  <a:schemeClr val="tx1">
+                    <a:lumMod val="65000"/>
+                    <a:lumOff val="35000"/>
+                  </a:schemeClr>
+                </a:solidFill>
+              </a:ln>
+            </p:spPr>
+            <p:style>
+              <a:lnRef idx="2">
+                <a:schemeClr val="accent1">
+                  <a:shade val="15000"/>
+                </a:schemeClr>
+              </a:lnRef>
+              <a:fillRef idx="1">
+                <a:schemeClr val="accent1"/>
+              </a:fillRef>
+              <a:effectRef idx="0">
+                <a:schemeClr val="accent1"/>
+              </a:effectRef>
+              <a:fontRef idx="minor">
+                <a:schemeClr val="lt1"/>
+              </a:fontRef>
+            </p:style>
+            <p:txBody>
+              <a:bodyPr rtlCol="0" anchor="ctr"/>
+              <a:lstStyle/>
+              <a:p>
+                <a:pPr algn="ctr"/>
+                <a:endParaRPr lang="it-IT" sz="800"/>
+              </a:p>
+            </p:txBody>
+          </p:sp>
+        </p:grpSp>
       </p:grpSp>
-      <p:sp>
-        <p:nvSpPr>
-          <p:cNvPr id="102" name="TextBox 101">
-            <a:extLst>
-              <a:ext uri="{FF2B5EF4-FFF2-40B4-BE49-F238E27FC236}">
-                <a16:creationId xmlns:a16="http://schemas.microsoft.com/office/drawing/2014/main" id="{AEF2F405-62A6-9184-E2DA-F8586E4DAAA1}"/>
-              </a:ext>
-            </a:extLst>
-          </p:cNvPr>
-          <p:cNvSpPr txBox="1"/>
-          <p:nvPr/>
-        </p:nvSpPr>
-        <p:spPr>
-          <a:xfrm>
-            <a:off x="396600" y="1910964"/>
-            <a:ext cx="1188000" cy="615553"/>
-          </a:xfrm>
-          <a:prstGeom prst="rect">
-            <a:avLst/>
-          </a:prstGeom>
-          <a:solidFill>
-            <a:srgbClr val="DBC1AF"/>
-          </a:solidFill>
-          <a:ln w="3175">
-            <a:solidFill>
-              <a:schemeClr val="tx1">
-                <a:lumMod val="65000"/>
-                <a:lumOff val="35000"/>
-              </a:schemeClr>
-            </a:solidFill>
-          </a:ln>
-        </p:spPr>
-        <p:txBody>
-          <a:bodyPr wrap="square" rtlCol="0">
-            <a:spAutoFit/>
-          </a:bodyPr>
-          <a:lstStyle/>
-          <a:p>
-            <a:pPr algn="ctr"/>
-            <a:r>
-              <a:rPr lang="en-US" sz="1000" dirty="0">
-                <a:solidFill>
-                  <a:srgbClr val="333333"/>
-                </a:solidFill>
-                <a:latin typeface="Calibri Light" panose="020F0302020204030204" pitchFamily="34" charset="0"/>
-                <a:cs typeface="Calibri Light" panose="020F0302020204030204" pitchFamily="34" charset="0"/>
-              </a:rPr>
-              <a:t>Non-event</a:t>
-            </a:r>
-          </a:p>
-          <a:p>
-            <a:pPr algn="ctr"/>
-            <a:r>
-              <a:rPr lang="en-US" sz="1000" dirty="0">
-                <a:solidFill>
-                  <a:srgbClr val="333333"/>
-                </a:solidFill>
-                <a:latin typeface="Calibri Light" panose="020F0302020204030204" pitchFamily="34" charset="0"/>
-                <a:cs typeface="Calibri Light" panose="020F0302020204030204" pitchFamily="34" charset="0"/>
-              </a:rPr>
-              <a:t>(no flash flood risk)</a:t>
-            </a:r>
-          </a:p>
-          <a:p>
-            <a:pPr algn="ctr"/>
-            <a:r>
-              <a:rPr lang="en-US" sz="1400" b="1" dirty="0">
-                <a:solidFill>
-                  <a:srgbClr val="333333"/>
-                </a:solidFill>
-                <a:latin typeface="Calibri" panose="020F0502020204030204" pitchFamily="34" charset="0"/>
-                <a:ea typeface="Calibri" panose="020F0502020204030204" pitchFamily="34" charset="0"/>
-                <a:cs typeface="Calibri" panose="020F0502020204030204" pitchFamily="34" charset="0"/>
-              </a:rPr>
-              <a:t>0</a:t>
-            </a:r>
-          </a:p>
-        </p:txBody>
-      </p:sp>
-      <p:sp>
-        <p:nvSpPr>
-          <p:cNvPr id="103" name="TextBox 102">
-            <a:extLst>
-              <a:ext uri="{FF2B5EF4-FFF2-40B4-BE49-F238E27FC236}">
-                <a16:creationId xmlns:a16="http://schemas.microsoft.com/office/drawing/2014/main" id="{3AC1E00C-7CC8-E558-16F9-CBB16592A278}"/>
-              </a:ext>
-            </a:extLst>
-          </p:cNvPr>
-          <p:cNvSpPr txBox="1"/>
-          <p:nvPr/>
-        </p:nvSpPr>
-        <p:spPr>
-          <a:xfrm>
-            <a:off x="1051934" y="1455507"/>
-            <a:ext cx="409203" cy="246221"/>
-          </a:xfrm>
-          <a:prstGeom prst="rect">
-            <a:avLst/>
-          </a:prstGeom>
-          <a:noFill/>
-          <a:ln w="3175">
-            <a:noFill/>
-          </a:ln>
-        </p:spPr>
-        <p:txBody>
-          <a:bodyPr wrap="square" rtlCol="0">
-            <a:spAutoFit/>
-          </a:bodyPr>
-          <a:lstStyle/>
-          <a:p>
-            <a:pPr algn="ctr"/>
-            <a:r>
-              <a:rPr lang="en-US" sz="1000" dirty="0">
-                <a:solidFill>
-                  <a:srgbClr val="333333"/>
-                </a:solidFill>
-                <a:latin typeface="Calibri Light" panose="020F0302020204030204" pitchFamily="34" charset="0"/>
-                <a:cs typeface="Calibri Light" panose="020F0302020204030204" pitchFamily="34" charset="0"/>
-              </a:rPr>
-              <a:t>NO</a:t>
-            </a:r>
-          </a:p>
-        </p:txBody>
-      </p:sp>
-      <p:sp>
-        <p:nvSpPr>
-          <p:cNvPr id="104" name="TextBox 103">
-            <a:extLst>
-              <a:ext uri="{FF2B5EF4-FFF2-40B4-BE49-F238E27FC236}">
-                <a16:creationId xmlns:a16="http://schemas.microsoft.com/office/drawing/2014/main" id="{E2C60F2E-5AEC-FD98-E016-93A8494C37D8}"/>
-              </a:ext>
-            </a:extLst>
-          </p:cNvPr>
-          <p:cNvSpPr txBox="1"/>
-          <p:nvPr/>
-        </p:nvSpPr>
-        <p:spPr>
-          <a:xfrm>
-            <a:off x="2608237" y="1455507"/>
-            <a:ext cx="409203" cy="246221"/>
-          </a:xfrm>
-          <a:prstGeom prst="rect">
-            <a:avLst/>
-          </a:prstGeom>
-          <a:noFill/>
-          <a:ln w="3175">
-            <a:noFill/>
-          </a:ln>
-        </p:spPr>
-        <p:txBody>
-          <a:bodyPr wrap="square" rtlCol="0">
-            <a:spAutoFit/>
-          </a:bodyPr>
-          <a:lstStyle/>
-          <a:p>
-            <a:pPr algn="ctr"/>
-            <a:r>
-              <a:rPr lang="en-US" sz="1000" dirty="0">
-                <a:solidFill>
-                  <a:srgbClr val="333333"/>
-                </a:solidFill>
-                <a:latin typeface="Calibri Light" panose="020F0302020204030204" pitchFamily="34" charset="0"/>
-                <a:cs typeface="Calibri Light" panose="020F0302020204030204" pitchFamily="34" charset="0"/>
-              </a:rPr>
-              <a:t>YES</a:t>
-            </a:r>
-          </a:p>
-        </p:txBody>
-      </p:sp>
-      <p:sp>
-        <p:nvSpPr>
-          <p:cNvPr id="105" name="TextBox 104">
-            <a:extLst>
-              <a:ext uri="{FF2B5EF4-FFF2-40B4-BE49-F238E27FC236}">
-                <a16:creationId xmlns:a16="http://schemas.microsoft.com/office/drawing/2014/main" id="{094E29AE-C474-3CCD-52C0-D085CCBD05CB}"/>
-              </a:ext>
-            </a:extLst>
-          </p:cNvPr>
-          <p:cNvSpPr txBox="1"/>
-          <p:nvPr/>
-        </p:nvSpPr>
-        <p:spPr>
-          <a:xfrm>
-            <a:off x="2471724" y="1918522"/>
-            <a:ext cx="1188000" cy="615553"/>
-          </a:xfrm>
-          <a:prstGeom prst="rect">
-            <a:avLst/>
-          </a:prstGeom>
-          <a:solidFill>
-            <a:srgbClr val="C1E5EC"/>
-          </a:solidFill>
-          <a:ln w="3175">
-            <a:solidFill>
-              <a:schemeClr val="tx1">
-                <a:lumMod val="65000"/>
-                <a:lumOff val="35000"/>
-              </a:schemeClr>
-            </a:solidFill>
-          </a:ln>
-        </p:spPr>
-        <p:txBody>
-          <a:bodyPr wrap="square" rtlCol="0">
-            <a:spAutoFit/>
-          </a:bodyPr>
-          <a:lstStyle/>
-          <a:p>
-            <a:pPr algn="ctr"/>
-            <a:r>
-              <a:rPr lang="en-US" sz="1000" dirty="0">
-                <a:solidFill>
-                  <a:srgbClr val="333333"/>
-                </a:solidFill>
-                <a:latin typeface="Calibri Light" panose="020F0302020204030204" pitchFamily="34" charset="0"/>
-                <a:cs typeface="Calibri Light" panose="020F0302020204030204" pitchFamily="34" charset="0"/>
-              </a:rPr>
-              <a:t>Yes-event</a:t>
-            </a:r>
-          </a:p>
-          <a:p>
-            <a:pPr algn="ctr"/>
-            <a:r>
-              <a:rPr lang="en-US" sz="1000" dirty="0">
-                <a:solidFill>
-                  <a:srgbClr val="333333"/>
-                </a:solidFill>
-                <a:latin typeface="Calibri Light" panose="020F0302020204030204" pitchFamily="34" charset="0"/>
-                <a:cs typeface="Calibri Light" panose="020F0302020204030204" pitchFamily="34" charset="0"/>
-              </a:rPr>
-              <a:t>(flash flood risk)</a:t>
-            </a:r>
-          </a:p>
-          <a:p>
-            <a:pPr algn="ctr"/>
-            <a:r>
-              <a:rPr lang="en-US" sz="1400" b="1" dirty="0">
-                <a:solidFill>
-                  <a:srgbClr val="32999E"/>
-                </a:solidFill>
-                <a:latin typeface="Calibri" panose="020F0502020204030204" pitchFamily="34" charset="0"/>
-                <a:ea typeface="Calibri" panose="020F0502020204030204" pitchFamily="34" charset="0"/>
-                <a:cs typeface="Calibri" panose="020F0502020204030204" pitchFamily="34" charset="0"/>
-              </a:rPr>
-              <a:t>1</a:t>
-            </a:r>
-          </a:p>
-        </p:txBody>
-      </p:sp>
-      <p:pic>
-        <p:nvPicPr>
-          <p:cNvPr id="106" name="Picture 105">
-            <a:extLst>
-              <a:ext uri="{FF2B5EF4-FFF2-40B4-BE49-F238E27FC236}">
-                <a16:creationId xmlns:a16="http://schemas.microsoft.com/office/drawing/2014/main" id="{BE52EE0A-1373-B866-C4C7-77A5B2CBCBC8}"/>
-              </a:ext>
-            </a:extLst>
-          </p:cNvPr>
-          <p:cNvPicPr>
-            <a:picLocks noChangeAspect="1"/>
-          </p:cNvPicPr>
-          <p:nvPr/>
-        </p:nvPicPr>
-        <p:blipFill>
-          <a:blip r:embed="rId3"/>
-          <a:stretch>
-            <a:fillRect/>
-          </a:stretch>
-        </p:blipFill>
-        <p:spPr>
-          <a:xfrm>
-            <a:off x="781156" y="3447517"/>
-            <a:ext cx="2499577" cy="998307"/>
-          </a:xfrm>
-          <a:prstGeom prst="rect">
-            <a:avLst/>
-          </a:prstGeom>
-        </p:spPr>
-      </p:pic>
-      <p:cxnSp>
-        <p:nvCxnSpPr>
-          <p:cNvPr id="107" name="Straight Connector 106">
-            <a:extLst>
-              <a:ext uri="{FF2B5EF4-FFF2-40B4-BE49-F238E27FC236}">
-                <a16:creationId xmlns:a16="http://schemas.microsoft.com/office/drawing/2014/main" id="{7D935352-A1CB-CD98-5B07-68B96108C511}"/>
-              </a:ext>
-            </a:extLst>
-          </p:cNvPr>
-          <p:cNvCxnSpPr>
-            <a:cxnSpLocks/>
-          </p:cNvCxnSpPr>
-          <p:nvPr/>
-        </p:nvCxnSpPr>
-        <p:spPr>
-          <a:xfrm rot="16200000">
-            <a:off x="2932454" y="2669137"/>
-            <a:ext cx="270000" cy="0"/>
-          </a:xfrm>
-          <a:prstGeom prst="line">
-            <a:avLst/>
-          </a:prstGeom>
-          <a:ln w="3175">
-            <a:solidFill>
-              <a:schemeClr val="tx1">
-                <a:lumMod val="65000"/>
-                <a:lumOff val="35000"/>
-              </a:schemeClr>
-            </a:solidFill>
-          </a:ln>
-        </p:spPr>
-        <p:style>
-          <a:lnRef idx="2">
-            <a:schemeClr val="accent1"/>
-          </a:lnRef>
-          <a:fillRef idx="0">
-            <a:schemeClr val="accent1"/>
-          </a:fillRef>
-          <a:effectRef idx="1">
-            <a:schemeClr val="accent1"/>
-          </a:effectRef>
-          <a:fontRef idx="minor">
-            <a:schemeClr val="tx1"/>
-          </a:fontRef>
-        </p:style>
-      </p:cxnSp>
-      <p:cxnSp>
-        <p:nvCxnSpPr>
-          <p:cNvPr id="108" name="Straight Arrow Connector 107">
-            <a:extLst>
-              <a:ext uri="{FF2B5EF4-FFF2-40B4-BE49-F238E27FC236}">
-                <a16:creationId xmlns:a16="http://schemas.microsoft.com/office/drawing/2014/main" id="{88DFB1B9-2D33-4164-D9A3-A66D31087C2A}"/>
-              </a:ext>
-            </a:extLst>
-          </p:cNvPr>
-          <p:cNvCxnSpPr>
-            <a:cxnSpLocks/>
-          </p:cNvCxnSpPr>
-          <p:nvPr/>
-        </p:nvCxnSpPr>
-        <p:spPr>
-          <a:xfrm flipH="1">
-            <a:off x="2030945" y="2813894"/>
-            <a:ext cx="0" cy="270000"/>
-          </a:xfrm>
-          <a:prstGeom prst="straightConnector1">
-            <a:avLst/>
-          </a:prstGeom>
-          <a:ln w="3175">
-            <a:solidFill>
-              <a:schemeClr val="tx1">
-                <a:lumMod val="65000"/>
-                <a:lumOff val="35000"/>
-              </a:schemeClr>
-            </a:solidFill>
-            <a:tailEnd type="triangle"/>
-          </a:ln>
-        </p:spPr>
-        <p:style>
-          <a:lnRef idx="2">
-            <a:schemeClr val="accent1"/>
-          </a:lnRef>
-          <a:fillRef idx="0">
-            <a:schemeClr val="accent1"/>
-          </a:fillRef>
-          <a:effectRef idx="1">
-            <a:schemeClr val="accent1"/>
-          </a:effectRef>
-          <a:fontRef idx="minor">
-            <a:schemeClr val="tx1"/>
-          </a:fontRef>
-        </p:style>
-      </p:cxnSp>
-      <p:cxnSp>
-        <p:nvCxnSpPr>
-          <p:cNvPr id="109" name="Straight Connector 108">
-            <a:extLst>
-              <a:ext uri="{FF2B5EF4-FFF2-40B4-BE49-F238E27FC236}">
-                <a16:creationId xmlns:a16="http://schemas.microsoft.com/office/drawing/2014/main" id="{858CED55-193B-AED5-D807-6ACCF9F7F9B2}"/>
-              </a:ext>
-            </a:extLst>
-          </p:cNvPr>
-          <p:cNvCxnSpPr>
-            <a:cxnSpLocks/>
-          </p:cNvCxnSpPr>
-          <p:nvPr/>
-        </p:nvCxnSpPr>
-        <p:spPr>
-          <a:xfrm rot="16200000">
-            <a:off x="859814" y="2669137"/>
-            <a:ext cx="270000" cy="0"/>
-          </a:xfrm>
-          <a:prstGeom prst="line">
-            <a:avLst/>
-          </a:prstGeom>
-          <a:ln w="3175">
-            <a:solidFill>
-              <a:schemeClr val="tx1">
-                <a:lumMod val="65000"/>
-                <a:lumOff val="35000"/>
-              </a:schemeClr>
-            </a:solidFill>
-          </a:ln>
-        </p:spPr>
-        <p:style>
-          <a:lnRef idx="2">
-            <a:schemeClr val="accent1"/>
-          </a:lnRef>
-          <a:fillRef idx="0">
-            <a:schemeClr val="accent1"/>
-          </a:fillRef>
-          <a:effectRef idx="1">
-            <a:schemeClr val="accent1"/>
-          </a:effectRef>
-          <a:fontRef idx="minor">
-            <a:schemeClr val="tx1"/>
-          </a:fontRef>
-        </p:style>
-      </p:cxnSp>
-      <p:cxnSp>
-        <p:nvCxnSpPr>
-          <p:cNvPr id="110" name="Straight Connector 109">
-            <a:extLst>
-              <a:ext uri="{FF2B5EF4-FFF2-40B4-BE49-F238E27FC236}">
-                <a16:creationId xmlns:a16="http://schemas.microsoft.com/office/drawing/2014/main" id="{81AA77C9-2BA6-9449-258D-DEDF65B8D8A9}"/>
-              </a:ext>
-            </a:extLst>
-          </p:cNvPr>
-          <p:cNvCxnSpPr>
-            <a:cxnSpLocks/>
-          </p:cNvCxnSpPr>
-          <p:nvPr/>
-        </p:nvCxnSpPr>
-        <p:spPr>
-          <a:xfrm flipV="1">
-            <a:off x="998220" y="2804137"/>
-            <a:ext cx="2067504" cy="9757"/>
-          </a:xfrm>
-          <a:prstGeom prst="line">
-            <a:avLst/>
-          </a:prstGeom>
-          <a:ln w="3175">
-            <a:solidFill>
-              <a:schemeClr val="tx1">
-                <a:lumMod val="65000"/>
-                <a:lumOff val="35000"/>
-              </a:schemeClr>
-            </a:solidFill>
-          </a:ln>
-        </p:spPr>
-        <p:style>
-          <a:lnRef idx="2">
-            <a:schemeClr val="accent1"/>
-          </a:lnRef>
-          <a:fillRef idx="0">
-            <a:schemeClr val="accent1"/>
-          </a:fillRef>
-          <a:effectRef idx="1">
-            <a:schemeClr val="accent1"/>
-          </a:effectRef>
-          <a:fontRef idx="minor">
-            <a:schemeClr val="tx1"/>
-          </a:fontRef>
-        </p:style>
-      </p:cxnSp>
-      <p:sp>
-        <p:nvSpPr>
-          <p:cNvPr id="111" name="TextBox 110">
-            <a:extLst>
-              <a:ext uri="{FF2B5EF4-FFF2-40B4-BE49-F238E27FC236}">
-                <a16:creationId xmlns:a16="http://schemas.microsoft.com/office/drawing/2014/main" id="{3041A462-13E8-E68B-ED83-34E69527A7C3}"/>
-              </a:ext>
-            </a:extLst>
-          </p:cNvPr>
-          <p:cNvSpPr txBox="1"/>
-          <p:nvPr/>
-        </p:nvSpPr>
-        <p:spPr>
-          <a:xfrm>
-            <a:off x="781153" y="3069840"/>
-            <a:ext cx="2499577" cy="400110"/>
-          </a:xfrm>
-          <a:prstGeom prst="rect">
-            <a:avLst/>
-          </a:prstGeom>
-          <a:noFill/>
-          <a:ln w="3175">
-            <a:noFill/>
-          </a:ln>
-        </p:spPr>
-        <p:txBody>
-          <a:bodyPr wrap="square" rtlCol="0">
-            <a:spAutoFit/>
-          </a:bodyPr>
-          <a:lstStyle/>
-          <a:p>
-            <a:pPr algn="ctr"/>
-            <a:r>
-              <a:rPr lang="en-US" sz="1000" dirty="0">
-                <a:solidFill>
-                  <a:srgbClr val="333333"/>
-                </a:solidFill>
-                <a:latin typeface="Calibri Light" panose="020F0302020204030204" pitchFamily="34" charset="0"/>
-                <a:cs typeface="Calibri Light" panose="020F0302020204030204" pitchFamily="34" charset="0"/>
-              </a:rPr>
-              <a:t>Rainfall-based predictions of areas at risk of flash floods (binary field)</a:t>
-            </a:r>
-          </a:p>
-        </p:txBody>
-      </p:sp>
-      <p:sp>
-        <p:nvSpPr>
-          <p:cNvPr id="112" name="Rectangle 111">
-            <a:extLst>
-              <a:ext uri="{FF2B5EF4-FFF2-40B4-BE49-F238E27FC236}">
-                <a16:creationId xmlns:a16="http://schemas.microsoft.com/office/drawing/2014/main" id="{0ABB75E4-DC24-C31B-F4F0-D6035B2DC0CC}"/>
-              </a:ext>
-            </a:extLst>
-          </p:cNvPr>
-          <p:cNvSpPr/>
-          <p:nvPr/>
-        </p:nvSpPr>
-        <p:spPr>
-          <a:xfrm>
-            <a:off x="723899" y="3078999"/>
-            <a:ext cx="2635145" cy="1424422"/>
-          </a:xfrm>
-          <a:prstGeom prst="rect">
-            <a:avLst/>
-          </a:prstGeom>
-          <a:noFill/>
-          <a:ln w="3175">
-            <a:solidFill>
-              <a:schemeClr val="tx1">
-                <a:lumMod val="65000"/>
-                <a:lumOff val="35000"/>
-              </a:schemeClr>
-            </a:solidFill>
-          </a:ln>
-        </p:spPr>
-        <p:style>
-          <a:lnRef idx="2">
-            <a:schemeClr val="accent1">
-              <a:shade val="15000"/>
-            </a:schemeClr>
-          </a:lnRef>
-          <a:fillRef idx="1">
-            <a:schemeClr val="accent1"/>
-          </a:fillRef>
-          <a:effectRef idx="0">
-            <a:schemeClr val="accent1"/>
-          </a:effectRef>
-          <a:fontRef idx="minor">
-            <a:schemeClr val="lt1"/>
-          </a:fontRef>
-        </p:style>
-        <p:txBody>
-          <a:bodyPr rtlCol="0" anchor="ctr"/>
-          <a:lstStyle/>
-          <a:p>
-            <a:pPr algn="ctr"/>
-            <a:endParaRPr lang="it-IT"/>
-          </a:p>
-        </p:txBody>
-      </p:sp>
     </p:spTree>
     <p:extLst>
       <p:ext uri="{BB962C8B-B14F-4D97-AF65-F5344CB8AC3E}">

</xml_diff>